<commit_message>
Add per-exercise slides for c++ 基礎知識 in the PPT
原本只有一張總表列出 c++ 基礎知識 的題目，現在改成每個練習各自一頁，
附上題目說明與程式碼片段，跟 演算法之美 的呈現方式一致。

Co-Authored-By: Claude Sonnet 5 <noreply@anthropic.com>
</commit_message>
<xml_diff>
--- a/practice_intro.pptx
+++ b/practice_intro.pptx
@@ -13,6 +13,13 @@
     <p:sldId id="261" r:id="rId12"/>
     <p:sldId id="262" r:id="rId13"/>
     <p:sldId id="263" r:id="rId14"/>
+    <p:sldId id="264" r:id="rId15"/>
+    <p:sldId id="265" r:id="rId16"/>
+    <p:sldId id="266" r:id="rId17"/>
+    <p:sldId id="267" r:id="rId18"/>
+    <p:sldId id="268" r:id="rId19"/>
+    <p:sldId id="269" r:id="rId20"/>
+    <p:sldId id="270" r:id="rId21"/>
   </p:sldIdLst>
   <p:sldSz cx="12191695" cy="6858000" type="screen4x3"/>
   <p:notesSz cx="6858000" cy="9144000"/>
@@ -3201,6 +3208,1801 @@
                 </a:solidFill>
               </a:rPr>
               <a:t>c++ 基礎知識 ・ 演算法之美</a:t>
+            </a:r>
+          </a:p>
+        </p:txBody>
+      </p:sp>
+    </p:spTree>
+  </p:cSld>
+  <p:clrMapOvr>
+    <a:masterClrMapping/>
+  </p:clrMapOvr>
+</p:sld>
+</file>
+
+<file path=ppt/slides/slide10.xml><?xml version="1.0" encoding="utf-8"?>
+<p:sld xmlns:a="http://schemas.openxmlformats.org/drawingml/2006/main" xmlns:p="http://schemas.openxmlformats.org/presentationml/2006/main" xmlns:r="http://schemas.openxmlformats.org/officeDocument/2006/relationships">
+  <p:cSld>
+    <p:spTree>
+      <p:nvGrpSpPr>
+        <p:cNvPr id="1" name=""/>
+        <p:cNvGrpSpPr/>
+        <p:nvPr/>
+      </p:nvGrpSpPr>
+      <p:grpSpPr/>
+      <p:sp>
+        <p:nvSpPr>
+          <p:cNvPr id="2" name="TextBox 1"/>
+          <p:cNvSpPr txBox="1"/>
+          <p:nvPr/>
+        </p:nvSpPr>
+        <p:spPr>
+          <a:xfrm>
+            <a:off x="548640" y="320040"/>
+            <a:ext cx="11064240" cy="914400"/>
+          </a:xfrm>
+          <a:prstGeom prst="rect">
+            <a:avLst/>
+          </a:prstGeom>
+          <a:noFill/>
+        </p:spPr>
+        <p:txBody>
+          <a:bodyPr wrap="square">
+            <a:spAutoFit/>
+          </a:bodyPr>
+          <a:lstStyle/>
+          <a:p>
+            <a:r>
+              <a:rPr sz="3200" b="1">
+                <a:solidFill>
+                  <a:srgbClr val="1F3B57"/>
+                </a:solidFill>
+              </a:rPr>
+              <a:t>c++ 基礎知識 — 練習11</a:t>
+            </a:r>
+          </a:p>
+        </p:txBody>
+      </p:sp>
+      <p:sp>
+        <p:nvSpPr>
+          <p:cNvPr id="3" name="Rectangle 2"/>
+          <p:cNvSpPr/>
+          <p:nvPr/>
+        </p:nvSpPr>
+        <p:spPr>
+          <a:xfrm>
+            <a:off x="0" y="1143000"/>
+            <a:ext cx="12191695" cy="54864"/>
+          </a:xfrm>
+          <a:prstGeom prst="rect">
+            <a:avLst/>
+          </a:prstGeom>
+          <a:solidFill>
+            <a:srgbClr val="2E86AB"/>
+          </a:solidFill>
+          <a:ln>
+            <a:noFill/>
+          </a:ln>
+          <a:effectLst/>
+        </p:spPr>
+        <p:style>
+          <a:lnRef idx="1">
+            <a:schemeClr val="accent1"/>
+          </a:lnRef>
+          <a:fillRef idx="3">
+            <a:schemeClr val="accent1"/>
+          </a:fillRef>
+          <a:effectRef idx="2">
+            <a:schemeClr val="accent1"/>
+          </a:effectRef>
+          <a:fontRef idx="minor">
+            <a:schemeClr val="lt1"/>
+          </a:fontRef>
+        </p:style>
+        <p:txBody>
+          <a:bodyPr rtlCol="0" anchor="ctr"/>
+          <a:lstStyle/>
+          <a:p>
+            <a:pPr algn="ctr"/>
+          </a:p>
+        </p:txBody>
+      </p:sp>
+      <p:sp>
+        <p:nvSpPr>
+          <p:cNvPr id="4" name="TextBox 3"/>
+          <p:cNvSpPr txBox="1"/>
+          <p:nvPr/>
+        </p:nvSpPr>
+        <p:spPr>
+          <a:xfrm>
+            <a:off x="548640" y="1371600"/>
+            <a:ext cx="11064240" cy="640080"/>
+          </a:xfrm>
+          <a:prstGeom prst="rect">
+            <a:avLst/>
+          </a:prstGeom>
+          <a:noFill/>
+        </p:spPr>
+        <p:txBody>
+          <a:bodyPr wrap="square">
+            <a:spAutoFit/>
+          </a:bodyPr>
+          <a:lstStyle/>
+          <a:p>
+            <a:r>
+              <a:rPr sz="1800">
+                <a:solidFill>
+                  <a:srgbClr val="2B2B2B"/>
+                </a:solidFill>
+              </a:rPr>
+              <a:t>給定 n 個整數的序列，作去重操作（保留原始出現順序）</a:t>
+            </a:r>
+          </a:p>
+        </p:txBody>
+      </p:sp>
+      <p:sp>
+        <p:nvSpPr>
+          <p:cNvPr id="5" name="TextBox 4"/>
+          <p:cNvSpPr txBox="1"/>
+          <p:nvPr/>
+        </p:nvSpPr>
+        <p:spPr>
+          <a:xfrm>
+            <a:off x="548640" y="2103120"/>
+            <a:ext cx="11064240" cy="4114800"/>
+          </a:xfrm>
+          <a:prstGeom prst="rect">
+            <a:avLst/>
+          </a:prstGeom>
+          <a:solidFill>
+            <a:srgbClr val="F4F4F4"/>
+          </a:solidFill>
+          <a:ln w="9525">
+            <a:solidFill>
+              <a:srgbClr val="D0D0D0"/>
+            </a:solidFill>
+          </a:ln>
+        </p:spPr>
+        <p:txBody>
+          <a:bodyPr wrap="square" lIns="137160" rIns="137160" tIns="91440" bIns="91440">
+            <a:spAutoFit/>
+          </a:bodyPr>
+          <a:lstStyle/>
+          <a:p>
+            <a:r>
+              <a:rPr sz="1400">
+                <a:solidFill>
+                  <a:srgbClr val="333333"/>
+                </a:solidFill>
+                <a:latin typeface="Consolas"/>
+              </a:rPr>
+              <a:t>vector&lt;int&gt; result;</a:t>
+            </a:r>
+          </a:p>
+          <a:p>
+            <a:r>
+              <a:rPr sz="1400">
+                <a:solidFill>
+                  <a:srgbClr val="333333"/>
+                </a:solidFill>
+                <a:latin typeface="Consolas"/>
+              </a:rPr>
+              <a:t>unordered_set&lt;int&gt; seen;</a:t>
+            </a:r>
+          </a:p>
+          <a:p>
+            <a:r>
+              <a:rPr sz="1400">
+                <a:solidFill>
+                  <a:srgbClr val="333333"/>
+                </a:solidFill>
+                <a:latin typeface="Consolas"/>
+              </a:rPr>
+              <a:t>for (int i = 0; i &lt; n; i++) {</a:t>
+            </a:r>
+          </a:p>
+          <a:p>
+            <a:r>
+              <a:rPr sz="1400">
+                <a:solidFill>
+                  <a:srgbClr val="333333"/>
+                </a:solidFill>
+                <a:latin typeface="Consolas"/>
+              </a:rPr>
+              <a:t>    int x;</a:t>
+            </a:r>
+          </a:p>
+          <a:p>
+            <a:r>
+              <a:rPr sz="1400">
+                <a:solidFill>
+                  <a:srgbClr val="333333"/>
+                </a:solidFill>
+                <a:latin typeface="Consolas"/>
+              </a:rPr>
+              <a:t>    cin &gt;&gt; x;</a:t>
+            </a:r>
+          </a:p>
+          <a:p>
+            <a:r>
+              <a:rPr sz="1400">
+                <a:solidFill>
+                  <a:srgbClr val="333333"/>
+                </a:solidFill>
+                <a:latin typeface="Consolas"/>
+              </a:rPr>
+              <a:t>    if (seen.insert(x).second) // 第一次出現才留下</a:t>
+            </a:r>
+          </a:p>
+          <a:p>
+            <a:r>
+              <a:rPr sz="1400">
+                <a:solidFill>
+                  <a:srgbClr val="333333"/>
+                </a:solidFill>
+                <a:latin typeface="Consolas"/>
+              </a:rPr>
+              <a:t>        result.push_back(x);</a:t>
+            </a:r>
+          </a:p>
+          <a:p>
+            <a:r>
+              <a:rPr sz="1400">
+                <a:solidFill>
+                  <a:srgbClr val="333333"/>
+                </a:solidFill>
+                <a:latin typeface="Consolas"/>
+              </a:rPr>
+              <a:t>}</a:t>
+            </a:r>
+          </a:p>
+          <a:p>
+            <a:r>
+              <a:rPr sz="1400">
+                <a:solidFill>
+                  <a:srgbClr val="333333"/>
+                </a:solidFill>
+                <a:latin typeface="Consolas"/>
+              </a:rPr>
+              <a:t>for (int i = 0; i &lt; (int)result.size(); i++)</a:t>
+            </a:r>
+          </a:p>
+          <a:p>
+            <a:r>
+              <a:rPr sz="1400">
+                <a:solidFill>
+                  <a:srgbClr val="333333"/>
+                </a:solidFill>
+                <a:latin typeface="Consolas"/>
+              </a:rPr>
+              <a:t>    cout &lt;&lt; result[i] &lt;&lt; " \n"[i == (int)result.size() - 1];</a:t>
+            </a:r>
+          </a:p>
+        </p:txBody>
+      </p:sp>
+      <p:sp>
+        <p:nvSpPr>
+          <p:cNvPr id="6" name="TextBox 5"/>
+          <p:cNvSpPr txBox="1"/>
+          <p:nvPr/>
+        </p:nvSpPr>
+        <p:spPr>
+          <a:xfrm>
+            <a:off x="548640" y="6446520"/>
+            <a:ext cx="11064240" cy="320040"/>
+          </a:xfrm>
+          <a:prstGeom prst="rect">
+            <a:avLst/>
+          </a:prstGeom>
+          <a:noFill/>
+        </p:spPr>
+        <p:txBody>
+          <a:bodyPr wrap="none">
+            <a:spAutoFit/>
+          </a:bodyPr>
+          <a:lstStyle/>
+          <a:p>
+            <a:r>
+              <a:rPr sz="1200">
+                <a:solidFill>
+                  <a:srgbClr val="999999"/>
+                </a:solidFill>
+              </a:rPr>
+              <a:t>c++ 基礎知識/練習11.cpp</a:t>
+            </a:r>
+          </a:p>
+        </p:txBody>
+      </p:sp>
+    </p:spTree>
+  </p:cSld>
+  <p:clrMapOvr>
+    <a:masterClrMapping/>
+  </p:clrMapOvr>
+</p:sld>
+</file>
+
+<file path=ppt/slides/slide11.xml><?xml version="1.0" encoding="utf-8"?>
+<p:sld xmlns:a="http://schemas.openxmlformats.org/drawingml/2006/main" xmlns:p="http://schemas.openxmlformats.org/presentationml/2006/main" xmlns:r="http://schemas.openxmlformats.org/officeDocument/2006/relationships">
+  <p:cSld>
+    <p:spTree>
+      <p:nvGrpSpPr>
+        <p:cNvPr id="1" name=""/>
+        <p:cNvGrpSpPr/>
+        <p:nvPr/>
+      </p:nvGrpSpPr>
+      <p:grpSpPr/>
+      <p:sp>
+        <p:nvSpPr>
+          <p:cNvPr id="2" name="TextBox 1"/>
+          <p:cNvSpPr txBox="1"/>
+          <p:nvPr/>
+        </p:nvSpPr>
+        <p:spPr>
+          <a:xfrm>
+            <a:off x="548640" y="320040"/>
+            <a:ext cx="11064240" cy="914400"/>
+          </a:xfrm>
+          <a:prstGeom prst="rect">
+            <a:avLst/>
+          </a:prstGeom>
+          <a:noFill/>
+        </p:spPr>
+        <p:txBody>
+          <a:bodyPr wrap="square">
+            <a:spAutoFit/>
+          </a:bodyPr>
+          <a:lstStyle/>
+          <a:p>
+            <a:r>
+              <a:rPr sz="3600" b="1">
+                <a:solidFill>
+                  <a:srgbClr val="1F3B57"/>
+                </a:solidFill>
+              </a:rPr>
+              <a:t>演算法之美 — 練習1</a:t>
+            </a:r>
+          </a:p>
+        </p:txBody>
+      </p:sp>
+      <p:sp>
+        <p:nvSpPr>
+          <p:cNvPr id="3" name="Rectangle 2"/>
+          <p:cNvSpPr/>
+          <p:nvPr/>
+        </p:nvSpPr>
+        <p:spPr>
+          <a:xfrm>
+            <a:off x="0" y="1143000"/>
+            <a:ext cx="12191695" cy="54864"/>
+          </a:xfrm>
+          <a:prstGeom prst="rect">
+            <a:avLst/>
+          </a:prstGeom>
+          <a:solidFill>
+            <a:srgbClr val="2E86AB"/>
+          </a:solidFill>
+          <a:ln>
+            <a:noFill/>
+          </a:ln>
+          <a:effectLst/>
+        </p:spPr>
+        <p:style>
+          <a:lnRef idx="1">
+            <a:schemeClr val="accent1"/>
+          </a:lnRef>
+          <a:fillRef idx="3">
+            <a:schemeClr val="accent1"/>
+          </a:fillRef>
+          <a:effectRef idx="2">
+            <a:schemeClr val="accent1"/>
+          </a:effectRef>
+          <a:fontRef idx="minor">
+            <a:schemeClr val="lt1"/>
+          </a:fontRef>
+        </p:style>
+        <p:txBody>
+          <a:bodyPr rtlCol="0" anchor="ctr"/>
+          <a:lstStyle/>
+          <a:p>
+            <a:pPr algn="ctr"/>
+          </a:p>
+        </p:txBody>
+      </p:sp>
+      <p:sp>
+        <p:nvSpPr>
+          <p:cNvPr id="4" name="TextBox 3"/>
+          <p:cNvSpPr txBox="1"/>
+          <p:nvPr/>
+        </p:nvSpPr>
+        <p:spPr>
+          <a:xfrm>
+            <a:off x="548640" y="1463040"/>
+            <a:ext cx="11064240" cy="4846320"/>
+          </a:xfrm>
+          <a:prstGeom prst="rect">
+            <a:avLst/>
+          </a:prstGeom>
+          <a:noFill/>
+        </p:spPr>
+        <p:txBody>
+          <a:bodyPr wrap="square">
+            <a:spAutoFit/>
+          </a:bodyPr>
+          <a:lstStyle/>
+          <a:p>
+            <a:pPr>
+              <a:spcAft>
+                <a:spcPts val="1000"/>
+              </a:spcAft>
+            </a:pPr>
+            <a:r>
+              <a:rPr sz="2200">
+                <a:solidFill>
+                  <a:srgbClr val="2B2B2B"/>
+                </a:solidFill>
+              </a:rPr>
+              <a:t>題目：輸入 x, y，輸出 [x, y] 區間閏年的數量，並在下一行輸出所有閏年的年份數字</a:t>
+            </a:r>
+          </a:p>
+          <a:p>
+            <a:pPr>
+              <a:spcAft>
+                <a:spcPts val="1000"/>
+              </a:spcAft>
+            </a:pPr>
+            <a:r>
+              <a:rPr sz="2200">
+                <a:solidFill>
+                  <a:srgbClr val="2B2B2B"/>
+                </a:solidFill>
+              </a:rPr>
+              <a:t>重點：不只是解題，更展示了如何發現並改進程式碼中的潛在風險</a:t>
+            </a:r>
+          </a:p>
+        </p:txBody>
+      </p:sp>
+      <p:sp>
+        <p:nvSpPr>
+          <p:cNvPr id="5" name="TextBox 4"/>
+          <p:cNvSpPr txBox="1"/>
+          <p:nvPr/>
+        </p:nvSpPr>
+        <p:spPr>
+          <a:xfrm>
+            <a:off x="548640" y="6446520"/>
+            <a:ext cx="11064240" cy="320040"/>
+          </a:xfrm>
+          <a:prstGeom prst="rect">
+            <a:avLst/>
+          </a:prstGeom>
+          <a:noFill/>
+        </p:spPr>
+        <p:txBody>
+          <a:bodyPr wrap="none">
+            <a:spAutoFit/>
+          </a:bodyPr>
+          <a:lstStyle/>
+          <a:p>
+            <a:r>
+              <a:rPr sz="1200">
+                <a:solidFill>
+                  <a:srgbClr val="999999"/>
+                </a:solidFill>
+              </a:rPr>
+              <a:t>演算法之美/練習1.cpp</a:t>
+            </a:r>
+          </a:p>
+        </p:txBody>
+      </p:sp>
+    </p:spTree>
+  </p:cSld>
+  <p:clrMapOvr>
+    <a:masterClrMapping/>
+  </p:clrMapOvr>
+</p:sld>
+</file>
+
+<file path=ppt/slides/slide12.xml><?xml version="1.0" encoding="utf-8"?>
+<p:sld xmlns:a="http://schemas.openxmlformats.org/drawingml/2006/main" xmlns:p="http://schemas.openxmlformats.org/presentationml/2006/main" xmlns:r="http://schemas.openxmlformats.org/officeDocument/2006/relationships">
+  <p:cSld>
+    <p:spTree>
+      <p:nvGrpSpPr>
+        <p:cNvPr id="1" name=""/>
+        <p:cNvGrpSpPr/>
+        <p:nvPr/>
+      </p:nvGrpSpPr>
+      <p:grpSpPr/>
+      <p:sp>
+        <p:nvSpPr>
+          <p:cNvPr id="2" name="TextBox 1"/>
+          <p:cNvSpPr txBox="1"/>
+          <p:nvPr/>
+        </p:nvSpPr>
+        <p:spPr>
+          <a:xfrm>
+            <a:off x="548640" y="320040"/>
+            <a:ext cx="11064240" cy="914400"/>
+          </a:xfrm>
+          <a:prstGeom prst="rect">
+            <a:avLst/>
+          </a:prstGeom>
+          <a:noFill/>
+        </p:spPr>
+        <p:txBody>
+          <a:bodyPr wrap="square">
+            <a:spAutoFit/>
+          </a:bodyPr>
+          <a:lstStyle/>
+          <a:p>
+            <a:r>
+              <a:rPr sz="3200" b="1">
+                <a:solidFill>
+                  <a:srgbClr val="1F3B57"/>
+                </a:solidFill>
+              </a:rPr>
+              <a:t>原始版本：固定大小陣列的風險</a:t>
+            </a:r>
+          </a:p>
+        </p:txBody>
+      </p:sp>
+      <p:sp>
+        <p:nvSpPr>
+          <p:cNvPr id="3" name="Rectangle 2"/>
+          <p:cNvSpPr/>
+          <p:nvPr/>
+        </p:nvSpPr>
+        <p:spPr>
+          <a:xfrm>
+            <a:off x="0" y="1143000"/>
+            <a:ext cx="12191695" cy="54864"/>
+          </a:xfrm>
+          <a:prstGeom prst="rect">
+            <a:avLst/>
+          </a:prstGeom>
+          <a:solidFill>
+            <a:srgbClr val="2E86AB"/>
+          </a:solidFill>
+          <a:ln>
+            <a:noFill/>
+          </a:ln>
+          <a:effectLst/>
+        </p:spPr>
+        <p:style>
+          <a:lnRef idx="1">
+            <a:schemeClr val="accent1"/>
+          </a:lnRef>
+          <a:fillRef idx="3">
+            <a:schemeClr val="accent1"/>
+          </a:fillRef>
+          <a:effectRef idx="2">
+            <a:schemeClr val="accent1"/>
+          </a:effectRef>
+          <a:fontRef idx="minor">
+            <a:schemeClr val="lt1"/>
+          </a:fontRef>
+        </p:style>
+        <p:txBody>
+          <a:bodyPr rtlCol="0" anchor="ctr"/>
+          <a:lstStyle/>
+          <a:p>
+            <a:pPr algn="ctr"/>
+          </a:p>
+        </p:txBody>
+      </p:sp>
+      <p:sp>
+        <p:nvSpPr>
+          <p:cNvPr id="4" name="TextBox 3"/>
+          <p:cNvSpPr txBox="1"/>
+          <p:nvPr/>
+        </p:nvSpPr>
+        <p:spPr>
+          <a:xfrm>
+            <a:off x="548640" y="1554480"/>
+            <a:ext cx="6400800" cy="2743200"/>
+          </a:xfrm>
+          <a:prstGeom prst="rect">
+            <a:avLst/>
+          </a:prstGeom>
+          <a:solidFill>
+            <a:srgbClr val="F4F4F4"/>
+          </a:solidFill>
+          <a:ln w="9525">
+            <a:solidFill>
+              <a:srgbClr val="D0D0D0"/>
+            </a:solidFill>
+          </a:ln>
+        </p:spPr>
+        <p:txBody>
+          <a:bodyPr wrap="square" lIns="137160" rIns="137160" tIns="91440" bIns="91440">
+            <a:spAutoFit/>
+          </a:bodyPr>
+          <a:lstStyle/>
+          <a:p>
+            <a:r>
+              <a:rPr sz="1600">
+                <a:solidFill>
+                  <a:srgbClr val="333333"/>
+                </a:solidFill>
+                <a:latin typeface="Consolas"/>
+              </a:rPr>
+              <a:t>int ans[1000];</a:t>
+            </a:r>
+          </a:p>
+          <a:p>
+            <a:r>
+              <a:rPr sz="1600">
+                <a:solidFill>
+                  <a:srgbClr val="333333"/>
+                </a:solidFill>
+                <a:latin typeface="Consolas"/>
+              </a:rPr>
+              <a:t/>
+            </a:r>
+          </a:p>
+          <a:p>
+            <a:r>
+              <a:rPr sz="1600">
+                <a:solidFill>
+                  <a:srgbClr val="333333"/>
+                </a:solidFill>
+                <a:latin typeface="Consolas"/>
+              </a:rPr>
+              <a:t>for (int i = x; i &lt;= y; i++) {</a:t>
+            </a:r>
+          </a:p>
+          <a:p>
+            <a:r>
+              <a:rPr sz="1600">
+                <a:solidFill>
+                  <a:srgbClr val="333333"/>
+                </a:solidFill>
+                <a:latin typeface="Consolas"/>
+              </a:rPr>
+              <a:t>    if (judge(i)) {</a:t>
+            </a:r>
+          </a:p>
+          <a:p>
+            <a:r>
+              <a:rPr sz="1600">
+                <a:solidFill>
+                  <a:srgbClr val="333333"/>
+                </a:solidFill>
+                <a:latin typeface="Consolas"/>
+              </a:rPr>
+              <a:t>        ans[cnt++] = i;   // cnt 超過 1000 就會越界！</a:t>
+            </a:r>
+          </a:p>
+          <a:p>
+            <a:r>
+              <a:rPr sz="1600">
+                <a:solidFill>
+                  <a:srgbClr val="333333"/>
+                </a:solidFill>
+                <a:latin typeface="Consolas"/>
+              </a:rPr>
+              <a:t>    }</a:t>
+            </a:r>
+          </a:p>
+          <a:p>
+            <a:r>
+              <a:rPr sz="1600">
+                <a:solidFill>
+                  <a:srgbClr val="333333"/>
+                </a:solidFill>
+                <a:latin typeface="Consolas"/>
+              </a:rPr>
+              <a:t>}</a:t>
+            </a:r>
+          </a:p>
+        </p:txBody>
+      </p:sp>
+      <p:sp>
+        <p:nvSpPr>
+          <p:cNvPr id="5" name="TextBox 4"/>
+          <p:cNvSpPr txBox="1"/>
+          <p:nvPr/>
+        </p:nvSpPr>
+        <p:spPr>
+          <a:xfrm>
+            <a:off x="7223760" y="1554480"/>
+            <a:ext cx="4480560" cy="4389120"/>
+          </a:xfrm>
+          <a:prstGeom prst="rect">
+            <a:avLst/>
+          </a:prstGeom>
+          <a:noFill/>
+        </p:spPr>
+        <p:txBody>
+          <a:bodyPr wrap="square">
+            <a:spAutoFit/>
+          </a:bodyPr>
+          <a:lstStyle/>
+          <a:p>
+            <a:pPr>
+              <a:spcAft>
+                <a:spcPts val="1000"/>
+              </a:spcAft>
+            </a:pPr>
+            <a:r>
+              <a:rPr sz="1600">
+                <a:solidFill>
+                  <a:srgbClr val="2B2B2B"/>
+                </a:solidFill>
+              </a:rPr>
+              <a:t>問題點：</a:t>
+            </a:r>
+          </a:p>
+          <a:p>
+            <a:pPr lvl="1">
+              <a:spcAft>
+                <a:spcPts val="1000"/>
+              </a:spcAft>
+            </a:pPr>
+            <a:r>
+              <a:rPr sz="1400">
+                <a:solidFill>
+                  <a:srgbClr val="2B2B2B"/>
+                </a:solidFill>
+              </a:rPr>
+              <a:t>陣列大小 1000 是憑經驗猜測的上限</a:t>
+            </a:r>
+          </a:p>
+          <a:p>
+            <a:pPr lvl="1">
+              <a:spcAft>
+                <a:spcPts val="1000"/>
+              </a:spcAft>
+            </a:pPr>
+            <a:r>
+              <a:rPr sz="1400">
+                <a:solidFill>
+                  <a:srgbClr val="2B2B2B"/>
+                </a:solidFill>
+              </a:rPr>
+              <a:t>若 [x, y] 區間夠大（例如 x=1, y=1000000），閏年數量會遠超過 1000</a:t>
+            </a:r>
+          </a:p>
+          <a:p>
+            <a:pPr lvl="1">
+              <a:spcAft>
+                <a:spcPts val="1000"/>
+              </a:spcAft>
+            </a:pPr>
+            <a:r>
+              <a:rPr sz="1400">
+                <a:solidFill>
+                  <a:srgbClr val="2B2B2B"/>
+                </a:solidFill>
+              </a:rPr>
+              <a:t>超出陣列邊界寫入 = 未定義行為（Undefined Behavior）</a:t>
+            </a:r>
+          </a:p>
+          <a:p>
+            <a:pPr lvl="1">
+              <a:spcAft>
+                <a:spcPts val="1000"/>
+              </a:spcAft>
+            </a:pPr>
+            <a:r>
+              <a:rPr sz="1400">
+                <a:solidFill>
+                  <a:srgbClr val="2B2B2B"/>
+                </a:solidFill>
+              </a:rPr>
+              <a:t>可能導致資料損毀、程式崩潰，且不易察覺、難以除錯</a:t>
+            </a:r>
+          </a:p>
+        </p:txBody>
+      </p:sp>
+      <p:sp>
+        <p:nvSpPr>
+          <p:cNvPr id="6" name="TextBox 5"/>
+          <p:cNvSpPr txBox="1"/>
+          <p:nvPr/>
+        </p:nvSpPr>
+        <p:spPr>
+          <a:xfrm>
+            <a:off x="548640" y="6446520"/>
+            <a:ext cx="11064240" cy="320040"/>
+          </a:xfrm>
+          <a:prstGeom prst="rect">
+            <a:avLst/>
+          </a:prstGeom>
+          <a:noFill/>
+        </p:spPr>
+        <p:txBody>
+          <a:bodyPr wrap="none">
+            <a:spAutoFit/>
+          </a:bodyPr>
+          <a:lstStyle/>
+          <a:p>
+            <a:r>
+              <a:rPr sz="1200">
+                <a:solidFill>
+                  <a:srgbClr val="999999"/>
+                </a:solidFill>
+              </a:rPr>
+              <a:t>演算法之美/練習1.cpp</a:t>
+            </a:r>
+          </a:p>
+        </p:txBody>
+      </p:sp>
+    </p:spTree>
+  </p:cSld>
+  <p:clrMapOvr>
+    <a:masterClrMapping/>
+  </p:clrMapOvr>
+</p:sld>
+</file>
+
+<file path=ppt/slides/slide13.xml><?xml version="1.0" encoding="utf-8"?>
+<p:sld xmlns:a="http://schemas.openxmlformats.org/drawingml/2006/main" xmlns:p="http://schemas.openxmlformats.org/presentationml/2006/main" xmlns:r="http://schemas.openxmlformats.org/officeDocument/2006/relationships">
+  <p:cSld>
+    <p:spTree>
+      <p:nvGrpSpPr>
+        <p:cNvPr id="1" name=""/>
+        <p:cNvGrpSpPr/>
+        <p:nvPr/>
+      </p:nvGrpSpPr>
+      <p:grpSpPr/>
+      <p:sp>
+        <p:nvSpPr>
+          <p:cNvPr id="2" name="TextBox 1"/>
+          <p:cNvSpPr txBox="1"/>
+          <p:nvPr/>
+        </p:nvSpPr>
+        <p:spPr>
+          <a:xfrm>
+            <a:off x="548640" y="320040"/>
+            <a:ext cx="11064240" cy="914400"/>
+          </a:xfrm>
+          <a:prstGeom prst="rect">
+            <a:avLst/>
+          </a:prstGeom>
+          <a:noFill/>
+        </p:spPr>
+        <p:txBody>
+          <a:bodyPr wrap="square">
+            <a:spAutoFit/>
+          </a:bodyPr>
+          <a:lstStyle/>
+          <a:p>
+            <a:r>
+              <a:rPr sz="3200" b="1">
+                <a:solidFill>
+                  <a:srgbClr val="1F3B57"/>
+                </a:solidFill>
+              </a:rPr>
+              <a:t>改進版本：std::vector 動態陣列</a:t>
+            </a:r>
+          </a:p>
+        </p:txBody>
+      </p:sp>
+      <p:sp>
+        <p:nvSpPr>
+          <p:cNvPr id="3" name="Rectangle 2"/>
+          <p:cNvSpPr/>
+          <p:nvPr/>
+        </p:nvSpPr>
+        <p:spPr>
+          <a:xfrm>
+            <a:off x="0" y="1143000"/>
+            <a:ext cx="12191695" cy="54864"/>
+          </a:xfrm>
+          <a:prstGeom prst="rect">
+            <a:avLst/>
+          </a:prstGeom>
+          <a:solidFill>
+            <a:srgbClr val="2E86AB"/>
+          </a:solidFill>
+          <a:ln>
+            <a:noFill/>
+          </a:ln>
+          <a:effectLst/>
+        </p:spPr>
+        <p:style>
+          <a:lnRef idx="1">
+            <a:schemeClr val="accent1"/>
+          </a:lnRef>
+          <a:fillRef idx="3">
+            <a:schemeClr val="accent1"/>
+          </a:fillRef>
+          <a:effectRef idx="2">
+            <a:schemeClr val="accent1"/>
+          </a:effectRef>
+          <a:fontRef idx="minor">
+            <a:schemeClr val="lt1"/>
+          </a:fontRef>
+        </p:style>
+        <p:txBody>
+          <a:bodyPr rtlCol="0" anchor="ctr"/>
+          <a:lstStyle/>
+          <a:p>
+            <a:pPr algn="ctr"/>
+          </a:p>
+        </p:txBody>
+      </p:sp>
+      <p:sp>
+        <p:nvSpPr>
+          <p:cNvPr id="4" name="TextBox 3"/>
+          <p:cNvSpPr txBox="1"/>
+          <p:nvPr/>
+        </p:nvSpPr>
+        <p:spPr>
+          <a:xfrm>
+            <a:off x="548640" y="1554480"/>
+            <a:ext cx="6400800" cy="3291840"/>
+          </a:xfrm>
+          <a:prstGeom prst="rect">
+            <a:avLst/>
+          </a:prstGeom>
+          <a:solidFill>
+            <a:srgbClr val="F4F4F4"/>
+          </a:solidFill>
+          <a:ln w="9525">
+            <a:solidFill>
+              <a:srgbClr val="D0D0D0"/>
+            </a:solidFill>
+          </a:ln>
+        </p:spPr>
+        <p:txBody>
+          <a:bodyPr wrap="square" lIns="137160" rIns="137160" tIns="91440" bIns="91440">
+            <a:spAutoFit/>
+          </a:bodyPr>
+          <a:lstStyle/>
+          <a:p>
+            <a:r>
+              <a:rPr sz="1500">
+                <a:solidFill>
+                  <a:srgbClr val="333333"/>
+                </a:solidFill>
+                <a:latin typeface="Consolas"/>
+              </a:rPr>
+              <a:t>vector&lt;int&gt; ans;   // 不用事先宣告大小</a:t>
+            </a:r>
+          </a:p>
+          <a:p>
+            <a:r>
+              <a:rPr sz="1500">
+                <a:solidFill>
+                  <a:srgbClr val="333333"/>
+                </a:solidFill>
+                <a:latin typeface="Consolas"/>
+              </a:rPr>
+              <a:t/>
+            </a:r>
+          </a:p>
+          <a:p>
+            <a:r>
+              <a:rPr sz="1500">
+                <a:solidFill>
+                  <a:srgbClr val="333333"/>
+                </a:solidFill>
+                <a:latin typeface="Consolas"/>
+              </a:rPr>
+              <a:t>for (int i = x; i &lt;= y; i++) {</a:t>
+            </a:r>
+          </a:p>
+          <a:p>
+            <a:r>
+              <a:rPr sz="1500">
+                <a:solidFill>
+                  <a:srgbClr val="333333"/>
+                </a:solidFill>
+                <a:latin typeface="Consolas"/>
+              </a:rPr>
+              <a:t>    if (judge(i)) {</a:t>
+            </a:r>
+          </a:p>
+          <a:p>
+            <a:r>
+              <a:rPr sz="1500">
+                <a:solidFill>
+                  <a:srgbClr val="333333"/>
+                </a:solidFill>
+                <a:latin typeface="Consolas"/>
+              </a:rPr>
+              <a:t>        ans.push_back(i);   // 自動成長，不會越界</a:t>
+            </a:r>
+          </a:p>
+          <a:p>
+            <a:r>
+              <a:rPr sz="1500">
+                <a:solidFill>
+                  <a:srgbClr val="333333"/>
+                </a:solidFill>
+                <a:latin typeface="Consolas"/>
+              </a:rPr>
+              <a:t>    }</a:t>
+            </a:r>
+          </a:p>
+          <a:p>
+            <a:r>
+              <a:rPr sz="1500">
+                <a:solidFill>
+                  <a:srgbClr val="333333"/>
+                </a:solidFill>
+                <a:latin typeface="Consolas"/>
+              </a:rPr>
+              <a:t>}</a:t>
+            </a:r>
+          </a:p>
+          <a:p>
+            <a:r>
+              <a:rPr sz="1500">
+                <a:solidFill>
+                  <a:srgbClr val="333333"/>
+                </a:solidFill>
+                <a:latin typeface="Consolas"/>
+              </a:rPr>
+              <a:t/>
+            </a:r>
+          </a:p>
+          <a:p>
+            <a:r>
+              <a:rPr sz="1500">
+                <a:solidFill>
+                  <a:srgbClr val="333333"/>
+                </a:solidFill>
+                <a:latin typeface="Consolas"/>
+              </a:rPr>
+              <a:t>cout &lt;&lt; ans.size() &lt;&lt; endl;</a:t>
+            </a:r>
+          </a:p>
+          <a:p>
+            <a:r>
+              <a:rPr sz="1500">
+                <a:solidFill>
+                  <a:srgbClr val="333333"/>
+                </a:solidFill>
+                <a:latin typeface="Consolas"/>
+              </a:rPr>
+              <a:t>for (int v : ans) cout &lt;&lt; v &lt;&lt; " ";</a:t>
+            </a:r>
+          </a:p>
+        </p:txBody>
+      </p:sp>
+      <p:sp>
+        <p:nvSpPr>
+          <p:cNvPr id="5" name="TextBox 4"/>
+          <p:cNvSpPr txBox="1"/>
+          <p:nvPr/>
+        </p:nvSpPr>
+        <p:spPr>
+          <a:xfrm>
+            <a:off x="7223760" y="1554480"/>
+            <a:ext cx="4480560" cy="4389120"/>
+          </a:xfrm>
+          <a:prstGeom prst="rect">
+            <a:avLst/>
+          </a:prstGeom>
+          <a:noFill/>
+        </p:spPr>
+        <p:txBody>
+          <a:bodyPr wrap="square">
+            <a:spAutoFit/>
+          </a:bodyPr>
+          <a:lstStyle/>
+          <a:p>
+            <a:pPr>
+              <a:spcAft>
+                <a:spcPts val="1000"/>
+              </a:spcAft>
+            </a:pPr>
+            <a:r>
+              <a:rPr sz="1600">
+                <a:solidFill>
+                  <a:srgbClr val="2B2B2B"/>
+                </a:solidFill>
+              </a:rPr>
+              <a:t>改進效果：</a:t>
+            </a:r>
+          </a:p>
+          <a:p>
+            <a:pPr lvl="1">
+              <a:spcAft>
+                <a:spcPts val="1000"/>
+              </a:spcAft>
+            </a:pPr>
+            <a:r>
+              <a:rPr sz="1400">
+                <a:solidFill>
+                  <a:srgbClr val="2B2B2B"/>
+                </a:solidFill>
+              </a:rPr>
+              <a:t>容量隨資料動態成長，無需事先猜測上限</a:t>
+            </a:r>
+          </a:p>
+          <a:p>
+            <a:pPr lvl="1">
+              <a:spcAft>
+                <a:spcPts val="1000"/>
+              </a:spcAft>
+            </a:pPr>
+            <a:r>
+              <a:rPr sz="1400">
+                <a:solidFill>
+                  <a:srgbClr val="2B2B2B"/>
+                </a:solidFill>
+              </a:rPr>
+              <a:t>消除陣列越界的未定義行為風險</a:t>
+            </a:r>
+          </a:p>
+          <a:p>
+            <a:pPr lvl="1">
+              <a:spcAft>
+                <a:spcPts val="1000"/>
+              </a:spcAft>
+            </a:pPr>
+            <a:r>
+              <a:rPr sz="1400">
+                <a:solidFill>
+                  <a:srgbClr val="2B2B2B"/>
+                </a:solidFill>
+              </a:rPr>
+              <a:t>程式碼更貼近「資料多大就存多大」的直覺</a:t>
+            </a:r>
+          </a:p>
+          <a:p>
+            <a:pPr lvl="1">
+              <a:spcAft>
+                <a:spcPts val="1000"/>
+              </a:spcAft>
+            </a:pPr>
+            <a:r>
+              <a:rPr sz="1400">
+                <a:solidFill>
+                  <a:srgbClr val="2B2B2B"/>
+                </a:solidFill>
+              </a:rPr>
+              <a:t>檔案：演算法之美/練習1-adviced.cpp</a:t>
+            </a:r>
+          </a:p>
+        </p:txBody>
+      </p:sp>
+      <p:sp>
+        <p:nvSpPr>
+          <p:cNvPr id="6" name="TextBox 5"/>
+          <p:cNvSpPr txBox="1"/>
+          <p:nvPr/>
+        </p:nvSpPr>
+        <p:spPr>
+          <a:xfrm>
+            <a:off x="548640" y="6446520"/>
+            <a:ext cx="11064240" cy="320040"/>
+          </a:xfrm>
+          <a:prstGeom prst="rect">
+            <a:avLst/>
+          </a:prstGeom>
+          <a:noFill/>
+        </p:spPr>
+        <p:txBody>
+          <a:bodyPr wrap="none">
+            <a:spAutoFit/>
+          </a:bodyPr>
+          <a:lstStyle/>
+          <a:p>
+            <a:r>
+              <a:rPr sz="1200">
+                <a:solidFill>
+                  <a:srgbClr val="999999"/>
+                </a:solidFill>
+              </a:rPr>
+              <a:t>演算法之美/練習1-adviced.cpp</a:t>
+            </a:r>
+          </a:p>
+        </p:txBody>
+      </p:sp>
+    </p:spTree>
+  </p:cSld>
+  <p:clrMapOvr>
+    <a:masterClrMapping/>
+  </p:clrMapOvr>
+</p:sld>
+</file>
+
+<file path=ppt/slides/slide14.xml><?xml version="1.0" encoding="utf-8"?>
+<p:sld xmlns:a="http://schemas.openxmlformats.org/drawingml/2006/main" xmlns:p="http://schemas.openxmlformats.org/presentationml/2006/main" xmlns:r="http://schemas.openxmlformats.org/officeDocument/2006/relationships">
+  <p:cSld>
+    <p:spTree>
+      <p:nvGrpSpPr>
+        <p:cNvPr id="1" name=""/>
+        <p:cNvGrpSpPr/>
+        <p:nvPr/>
+      </p:nvGrpSpPr>
+      <p:grpSpPr/>
+      <p:sp>
+        <p:nvSpPr>
+          <p:cNvPr id="2" name="TextBox 1"/>
+          <p:cNvSpPr txBox="1"/>
+          <p:nvPr/>
+        </p:nvSpPr>
+        <p:spPr>
+          <a:xfrm>
+            <a:off x="548640" y="320040"/>
+            <a:ext cx="11064240" cy="914400"/>
+          </a:xfrm>
+          <a:prstGeom prst="rect">
+            <a:avLst/>
+          </a:prstGeom>
+          <a:noFill/>
+        </p:spPr>
+        <p:txBody>
+          <a:bodyPr wrap="square">
+            <a:spAutoFit/>
+          </a:bodyPr>
+          <a:lstStyle/>
+          <a:p>
+            <a:r>
+              <a:rPr sz="3600" b="1">
+                <a:solidFill>
+                  <a:srgbClr val="1F3B57"/>
+                </a:solidFill>
+              </a:rPr>
+              <a:t>改進前後對照</a:t>
+            </a:r>
+          </a:p>
+        </p:txBody>
+      </p:sp>
+      <p:sp>
+        <p:nvSpPr>
+          <p:cNvPr id="3" name="Rectangle 2"/>
+          <p:cNvSpPr/>
+          <p:nvPr/>
+        </p:nvSpPr>
+        <p:spPr>
+          <a:xfrm>
+            <a:off x="0" y="1143000"/>
+            <a:ext cx="12191695" cy="54864"/>
+          </a:xfrm>
+          <a:prstGeom prst="rect">
+            <a:avLst/>
+          </a:prstGeom>
+          <a:solidFill>
+            <a:srgbClr val="2E86AB"/>
+          </a:solidFill>
+          <a:ln>
+            <a:noFill/>
+          </a:ln>
+          <a:effectLst/>
+        </p:spPr>
+        <p:style>
+          <a:lnRef idx="1">
+            <a:schemeClr val="accent1"/>
+          </a:lnRef>
+          <a:fillRef idx="3">
+            <a:schemeClr val="accent1"/>
+          </a:fillRef>
+          <a:effectRef idx="2">
+            <a:schemeClr val="accent1"/>
+          </a:effectRef>
+          <a:fontRef idx="minor">
+            <a:schemeClr val="lt1"/>
+          </a:fontRef>
+        </p:style>
+        <p:txBody>
+          <a:bodyPr rtlCol="0" anchor="ctr"/>
+          <a:lstStyle/>
+          <a:p>
+            <a:pPr algn="ctr"/>
+          </a:p>
+        </p:txBody>
+      </p:sp>
+      <p:graphicFrame>
+        <p:nvGraphicFramePr>
+          <p:cNvPr id="4" name="Table 3"/>
+          <p:cNvGraphicFramePr>
+            <a:graphicFrameLocks noGrp="1"/>
+          </p:cNvGraphicFramePr>
+          <p:nvPr/>
+        </p:nvGraphicFramePr>
+        <p:xfrm>
+          <a:off x="548640" y="1554480"/>
+          <a:ext cx="11064240" cy="4023360"/>
+        </p:xfrm>
+        <a:graphic>
+          <a:graphicData uri="http://schemas.openxmlformats.org/drawingml/2006/table">
+            <a:tbl>
+              <a:tblPr firstRow="1" bandRow="1">
+                <a:tableStyleId>{5C22544A-7EE6-4342-B048-85BDC9FD1C3A}</a:tableStyleId>
+              </a:tblPr>
+              <a:tblGrid>
+                <a:gridCol w="2377440"/>
+                <a:gridCol w="4343400"/>
+                <a:gridCol w="4343400"/>
+              </a:tblGrid>
+              <a:tr h="1005840">
+                <a:tc>
+                  <a:txBody>
+                    <a:bodyPr/>
+                    <a:lstStyle/>
+                    <a:p>
+                      <a:pPr>
+                        <a:defRPr b="1" sz="1600">
+                          <a:solidFill>
+                            <a:srgbClr val="FFFFFF"/>
+                          </a:solidFill>
+                        </a:defRPr>
+                      </a:pPr>
+                      <a:r>
+                        <a:t>項目</a:t>
+                      </a:r>
+                    </a:p>
+                  </a:txBody>
+                  <a:tcPr>
+                    <a:solidFill>
+                      <a:srgbClr val="2E86AB"/>
+                    </a:solidFill>
+                  </a:tcPr>
+                </a:tc>
+                <a:tc>
+                  <a:txBody>
+                    <a:bodyPr/>
+                    <a:lstStyle/>
+                    <a:p>
+                      <a:pPr>
+                        <a:defRPr b="1" sz="1600">
+                          <a:solidFill>
+                            <a:srgbClr val="FFFFFF"/>
+                          </a:solidFill>
+                        </a:defRPr>
+                      </a:pPr>
+                      <a:r>
+                        <a:t>原版 練習1.cpp</a:t>
+                      </a:r>
+                    </a:p>
+                  </a:txBody>
+                  <a:tcPr>
+                    <a:solidFill>
+                      <a:srgbClr val="2E86AB"/>
+                    </a:solidFill>
+                  </a:tcPr>
+                </a:tc>
+                <a:tc>
+                  <a:txBody>
+                    <a:bodyPr/>
+                    <a:lstStyle/>
+                    <a:p>
+                      <a:pPr>
+                        <a:defRPr b="1" sz="1600">
+                          <a:solidFill>
+                            <a:srgbClr val="FFFFFF"/>
+                          </a:solidFill>
+                        </a:defRPr>
+                      </a:pPr>
+                      <a:r>
+                        <a:t>改進版 練習1-adviced.cpp</a:t>
+                      </a:r>
+                    </a:p>
+                  </a:txBody>
+                  <a:tcPr>
+                    <a:solidFill>
+                      <a:srgbClr val="2E86AB"/>
+                    </a:solidFill>
+                  </a:tcPr>
+                </a:tc>
+              </a:tr>
+              <a:tr h="1005840">
+                <a:tc>
+                  <a:txBody>
+                    <a:bodyPr/>
+                    <a:lstStyle/>
+                    <a:p>
+                      <a:pPr>
+                        <a:defRPr sz="1400">
+                          <a:solidFill>
+                            <a:srgbClr val="2B2B2B"/>
+                          </a:solidFill>
+                        </a:defRPr>
+                      </a:pPr>
+                      <a:r>
+                        <a:t>資料結構</a:t>
+                      </a:r>
+                    </a:p>
+                  </a:txBody>
+                  <a:tcPr/>
+                </a:tc>
+                <a:tc>
+                  <a:txBody>
+                    <a:bodyPr/>
+                    <a:lstStyle/>
+                    <a:p>
+                      <a:pPr>
+                        <a:defRPr sz="1400">
+                          <a:solidFill>
+                            <a:srgbClr val="2B2B2B"/>
+                          </a:solidFill>
+                        </a:defRPr>
+                      </a:pPr>
+                      <a:r>
+                        <a:t>int ans[1000]（固定大小全域陣列）</a:t>
+                      </a:r>
+                    </a:p>
+                  </a:txBody>
+                  <a:tcPr/>
+                </a:tc>
+                <a:tc>
+                  <a:txBody>
+                    <a:bodyPr/>
+                    <a:lstStyle/>
+                    <a:p>
+                      <a:pPr>
+                        <a:defRPr sz="1400">
+                          <a:solidFill>
+                            <a:srgbClr val="2B2B2B"/>
+                          </a:solidFill>
+                        </a:defRPr>
+                      </a:pPr>
+                      <a:r>
+                        <a:t>std::vector&lt;int&gt;（動態陣列）</a:t>
+                      </a:r>
+                    </a:p>
+                  </a:txBody>
+                  <a:tcPr/>
+                </a:tc>
+              </a:tr>
+              <a:tr h="1005840">
+                <a:tc>
+                  <a:txBody>
+                    <a:bodyPr/>
+                    <a:lstStyle/>
+                    <a:p>
+                      <a:pPr>
+                        <a:defRPr sz="1400">
+                          <a:solidFill>
+                            <a:srgbClr val="2B2B2B"/>
+                          </a:solidFill>
+                        </a:defRPr>
+                      </a:pPr>
+                      <a:r>
+                        <a:t>容量上限</a:t>
+                      </a:r>
+                    </a:p>
+                  </a:txBody>
+                  <a:tcPr/>
+                </a:tc>
+                <a:tc>
+                  <a:txBody>
+                    <a:bodyPr/>
+                    <a:lstStyle/>
+                    <a:p>
+                      <a:pPr>
+                        <a:defRPr sz="1400">
+                          <a:solidFill>
+                            <a:srgbClr val="2B2B2B"/>
+                          </a:solidFill>
+                        </a:defRPr>
+                      </a:pPr>
+                      <a:r>
+                        <a:t>需事先猜測，寫死 1000</a:t>
+                      </a:r>
+                    </a:p>
+                  </a:txBody>
+                  <a:tcPr/>
+                </a:tc>
+                <a:tc>
+                  <a:txBody>
+                    <a:bodyPr/>
+                    <a:lstStyle/>
+                    <a:p>
+                      <a:pPr>
+                        <a:defRPr sz="1400">
+                          <a:solidFill>
+                            <a:srgbClr val="2B2B2B"/>
+                          </a:solidFill>
+                        </a:defRPr>
+                      </a:pPr>
+                      <a:r>
+                        <a:t>無需猜測，隨資料自動成長</a:t>
+                      </a:r>
+                    </a:p>
+                  </a:txBody>
+                  <a:tcPr/>
+                </a:tc>
+              </a:tr>
+              <a:tr h="1005840">
+                <a:tc>
+                  <a:txBody>
+                    <a:bodyPr/>
+                    <a:lstStyle/>
+                    <a:p>
+                      <a:pPr>
+                        <a:defRPr sz="1400">
+                          <a:solidFill>
+                            <a:srgbClr val="2B2B2B"/>
+                          </a:solidFill>
+                        </a:defRPr>
+                      </a:pPr>
+                      <a:r>
+                        <a:t>風險</a:t>
+                      </a:r>
+                    </a:p>
+                  </a:txBody>
+                  <a:tcPr/>
+                </a:tc>
+                <a:tc>
+                  <a:txBody>
+                    <a:bodyPr/>
+                    <a:lstStyle/>
+                    <a:p>
+                      <a:pPr>
+                        <a:defRPr sz="1400">
+                          <a:solidFill>
+                            <a:srgbClr val="2B2B2B"/>
+                          </a:solidFill>
+                        </a:defRPr>
+                      </a:pPr>
+                      <a:r>
+                        <a:t>超出 1000 筆時越界，UB</a:t>
+                      </a:r>
+                    </a:p>
+                  </a:txBody>
+                  <a:tcPr/>
+                </a:tc>
+                <a:tc>
+                  <a:txBody>
+                    <a:bodyPr/>
+                    <a:lstStyle/>
+                    <a:p>
+                      <a:pPr>
+                        <a:defRPr sz="1400">
+                          <a:solidFill>
+                            <a:srgbClr val="2B2B2B"/>
+                          </a:solidFill>
+                        </a:defRPr>
+                      </a:pPr>
+                      <a:r>
+                        <a:t>無越界風險</a:t>
+                      </a:r>
+                    </a:p>
+                  </a:txBody>
+                  <a:tcPr/>
+                </a:tc>
+              </a:tr>
+            </a:tbl>
+          </a:graphicData>
+        </a:graphic>
+      </p:graphicFrame>
+      <p:sp>
+        <p:nvSpPr>
+          <p:cNvPr id="5" name="TextBox 4"/>
+          <p:cNvSpPr txBox="1"/>
+          <p:nvPr/>
+        </p:nvSpPr>
+        <p:spPr>
+          <a:xfrm>
+            <a:off x="548640" y="6446520"/>
+            <a:ext cx="11064240" cy="320040"/>
+          </a:xfrm>
+          <a:prstGeom prst="rect">
+            <a:avLst/>
+          </a:prstGeom>
+          <a:noFill/>
+        </p:spPr>
+        <p:txBody>
+          <a:bodyPr wrap="none">
+            <a:spAutoFit/>
+          </a:bodyPr>
+          <a:lstStyle/>
+          <a:p>
+            <a:r>
+              <a:rPr sz="1200">
+                <a:solidFill>
+                  <a:srgbClr val="999999"/>
+                </a:solidFill>
+              </a:rPr>
+              <a:t>演算法之美/</a:t>
+            </a:r>
+          </a:p>
+        </p:txBody>
+      </p:sp>
+    </p:spTree>
+  </p:cSld>
+  <p:clrMapOvr>
+    <a:masterClrMapping/>
+  </p:clrMapOvr>
+</p:sld>
+</file>
+
+<file path=ppt/slides/slide15.xml><?xml version="1.0" encoding="utf-8"?>
+<p:sld xmlns:a="http://schemas.openxmlformats.org/drawingml/2006/main" xmlns:p="http://schemas.openxmlformats.org/presentationml/2006/main" xmlns:r="http://schemas.openxmlformats.org/officeDocument/2006/relationships">
+  <p:cSld>
+    <p:spTree>
+      <p:nvGrpSpPr>
+        <p:cNvPr id="1" name=""/>
+        <p:cNvGrpSpPr/>
+        <p:nvPr/>
+      </p:nvGrpSpPr>
+      <p:grpSpPr/>
+      <p:sp>
+        <p:nvSpPr>
+          <p:cNvPr id="2" name="TextBox 1"/>
+          <p:cNvSpPr txBox="1"/>
+          <p:nvPr/>
+        </p:nvSpPr>
+        <p:spPr>
+          <a:xfrm>
+            <a:off x="548640" y="320040"/>
+            <a:ext cx="11064240" cy="914400"/>
+          </a:xfrm>
+          <a:prstGeom prst="rect">
+            <a:avLst/>
+          </a:prstGeom>
+          <a:noFill/>
+        </p:spPr>
+        <p:txBody>
+          <a:bodyPr wrap="square">
+            <a:spAutoFit/>
+          </a:bodyPr>
+          <a:lstStyle/>
+          <a:p>
+            <a:r>
+              <a:rPr sz="3600" b="1">
+                <a:solidFill>
+                  <a:srgbClr val="1F3B57"/>
+                </a:solidFill>
+              </a:rPr>
+              <a:t>重點回顧</a:t>
+            </a:r>
+          </a:p>
+        </p:txBody>
+      </p:sp>
+      <p:sp>
+        <p:nvSpPr>
+          <p:cNvPr id="3" name="Rectangle 2"/>
+          <p:cNvSpPr/>
+          <p:nvPr/>
+        </p:nvSpPr>
+        <p:spPr>
+          <a:xfrm>
+            <a:off x="0" y="1143000"/>
+            <a:ext cx="12191695" cy="54864"/>
+          </a:xfrm>
+          <a:prstGeom prst="rect">
+            <a:avLst/>
+          </a:prstGeom>
+          <a:solidFill>
+            <a:srgbClr val="2E86AB"/>
+          </a:solidFill>
+          <a:ln>
+            <a:noFill/>
+          </a:ln>
+          <a:effectLst/>
+        </p:spPr>
+        <p:style>
+          <a:lnRef idx="1">
+            <a:schemeClr val="accent1"/>
+          </a:lnRef>
+          <a:fillRef idx="3">
+            <a:schemeClr val="accent1"/>
+          </a:fillRef>
+          <a:effectRef idx="2">
+            <a:schemeClr val="accent1"/>
+          </a:effectRef>
+          <a:fontRef idx="minor">
+            <a:schemeClr val="lt1"/>
+          </a:fontRef>
+        </p:style>
+        <p:txBody>
+          <a:bodyPr rtlCol="0" anchor="ctr"/>
+          <a:lstStyle/>
+          <a:p>
+            <a:pPr algn="ctr"/>
+          </a:p>
+        </p:txBody>
+      </p:sp>
+      <p:sp>
+        <p:nvSpPr>
+          <p:cNvPr id="4" name="TextBox 3"/>
+          <p:cNvSpPr txBox="1"/>
+          <p:nvPr/>
+        </p:nvSpPr>
+        <p:spPr>
+          <a:xfrm>
+            <a:off x="548640" y="1463040"/>
+            <a:ext cx="11064240" cy="4846320"/>
+          </a:xfrm>
+          <a:prstGeom prst="rect">
+            <a:avLst/>
+          </a:prstGeom>
+          <a:noFill/>
+        </p:spPr>
+        <p:txBody>
+          <a:bodyPr wrap="square">
+            <a:spAutoFit/>
+          </a:bodyPr>
+          <a:lstStyle/>
+          <a:p>
+            <a:pPr>
+              <a:spcAft>
+                <a:spcPts val="1000"/>
+              </a:spcAft>
+            </a:pPr>
+            <a:r>
+              <a:rPr sz="2200">
+                <a:solidFill>
+                  <a:srgbClr val="2B2B2B"/>
+                </a:solidFill>
+              </a:rPr>
+              <a:t>固定大小陣列必須「猜」容量，猜錯就會越界，是常見的 C++ 錯誤來源</a:t>
+            </a:r>
+          </a:p>
+          <a:p>
+            <a:pPr>
+              <a:spcAft>
+                <a:spcPts val="1000"/>
+              </a:spcAft>
+            </a:pPr>
+            <a:r>
+              <a:rPr sz="2200">
+                <a:solidFill>
+                  <a:srgbClr val="2B2B2B"/>
+                </a:solidFill>
+              </a:rPr>
+              <a:t>std::vector 提供動態成長的陣列，是更安全、更慣用的 C++ 寫法</a:t>
+            </a:r>
+          </a:p>
+          <a:p>
+            <a:pPr>
+              <a:spcAft>
+                <a:spcPts val="1000"/>
+              </a:spcAft>
+            </a:pPr>
+            <a:r>
+              <a:rPr sz="2200">
+                <a:solidFill>
+                  <a:srgbClr val="2B2B2B"/>
+                </a:solidFill>
+              </a:rPr>
+              <a:t>每個練習都可用同樣方式編譯測試：g++ 檔名.cpp -o 執行檔 &amp;&amp; ./執行檔</a:t>
+            </a:r>
+          </a:p>
+          <a:p>
+            <a:pPr>
+              <a:spcAft>
+                <a:spcPts val="1000"/>
+              </a:spcAft>
+            </a:pPr>
+            <a:r>
+              <a:rPr sz="2200">
+                <a:solidFill>
+                  <a:srgbClr val="2B2B2B"/>
+                </a:solidFill>
+              </a:rPr>
+              <a:t>README.md 是整個倉庫的題目索引，新增或修改題目時記得同步更新</a:t>
+            </a:r>
+          </a:p>
+        </p:txBody>
+      </p:sp>
+      <p:sp>
+        <p:nvSpPr>
+          <p:cNvPr id="5" name="TextBox 4"/>
+          <p:cNvSpPr txBox="1"/>
+          <p:nvPr/>
+        </p:nvSpPr>
+        <p:spPr>
+          <a:xfrm>
+            <a:off x="548640" y="6446520"/>
+            <a:ext cx="11064240" cy="320040"/>
+          </a:xfrm>
+          <a:prstGeom prst="rect">
+            <a:avLst/>
+          </a:prstGeom>
+          <a:noFill/>
+        </p:spPr>
+        <p:txBody>
+          <a:bodyPr wrap="none">
+            <a:spAutoFit/>
+          </a:bodyPr>
+          <a:lstStyle/>
+          <a:p>
+            <a:r>
+              <a:rPr sz="1200">
+                <a:solidFill>
+                  <a:srgbClr val="999999"/>
+                </a:solidFill>
+              </a:rPr>
+              <a:t>cplusplus_practice</a:t>
             </a:r>
           </a:p>
         </p:txBody>
@@ -3954,12 +5756,12 @@
           <a:lstStyle/>
           <a:p>
             <a:r>
-              <a:rPr sz="3600" b="1">
+              <a:rPr sz="3200" b="1">
                 <a:solidFill>
                   <a:srgbClr val="1F3B57"/>
                 </a:solidFill>
               </a:rPr>
-              <a:t>演算法之美 — 練習1</a:t>
+              <a:t>c++ 基礎知識 — 練習1</a:t>
             </a:r>
           </a:p>
         </p:txBody>
@@ -4016,8 +5818,8 @@
         </p:nvSpPr>
         <p:spPr>
           <a:xfrm>
-            <a:off x="548640" y="1463040"/>
-            <a:ext cx="11064240" cy="4846320"/>
+            <a:off x="548640" y="1371600"/>
+            <a:ext cx="11064240" cy="640080"/>
           </a:xfrm>
           <a:prstGeom prst="rect">
             <a:avLst/>
@@ -4030,33 +5832,13 @@
           </a:bodyPr>
           <a:lstStyle/>
           <a:p>
-            <a:pPr>
-              <a:spcAft>
-                <a:spcPts val="1000"/>
-              </a:spcAft>
-            </a:pPr>
-            <a:r>
-              <a:rPr sz="2200">
+            <a:r>
+              <a:rPr sz="1800">
                 <a:solidFill>
                   <a:srgbClr val="2B2B2B"/>
                 </a:solidFill>
               </a:rPr>
-              <a:t>題目：輸入 x, y，輸出 [x, y] 區間閏年的數量，並在下一行輸出所有閏年的年份數字</a:t>
-            </a:r>
-          </a:p>
-          <a:p>
-            <a:pPr>
-              <a:spcAft>
-                <a:spcPts val="1000"/>
-              </a:spcAft>
-            </a:pPr>
-            <a:r>
-              <a:rPr sz="2200">
-                <a:solidFill>
-                  <a:srgbClr val="2B2B2B"/>
-                </a:solidFill>
-              </a:rPr>
-              <a:t>重點：不只是解題，更展示了如何發現並改進程式碼中的潛在風險</a:t>
+              <a:t>輸入圓的半徑 r，輸出其直徑、圓周長和面積</a:t>
             </a:r>
           </a:p>
         </p:txBody>
@@ -4064,6 +5846,157 @@
       <p:sp>
         <p:nvSpPr>
           <p:cNvPr id="5" name="TextBox 4"/>
+          <p:cNvSpPr txBox="1"/>
+          <p:nvPr/>
+        </p:nvSpPr>
+        <p:spPr>
+          <a:xfrm>
+            <a:off x="548640" y="2103120"/>
+            <a:ext cx="11064240" cy="4114800"/>
+          </a:xfrm>
+          <a:prstGeom prst="rect">
+            <a:avLst/>
+          </a:prstGeom>
+          <a:solidFill>
+            <a:srgbClr val="F4F4F4"/>
+          </a:solidFill>
+          <a:ln w="9525">
+            <a:solidFill>
+              <a:srgbClr val="D0D0D0"/>
+            </a:solidFill>
+          </a:ln>
+        </p:spPr>
+        <p:txBody>
+          <a:bodyPr wrap="square" lIns="137160" rIns="137160" tIns="91440" bIns="91440">
+            <a:spAutoFit/>
+          </a:bodyPr>
+          <a:lstStyle/>
+          <a:p>
+            <a:r>
+              <a:rPr sz="1400">
+                <a:solidFill>
+                  <a:srgbClr val="333333"/>
+                </a:solidFill>
+                <a:latin typeface="Consolas"/>
+              </a:rPr>
+              <a:t>int main() {</a:t>
+            </a:r>
+          </a:p>
+          <a:p>
+            <a:r>
+              <a:rPr sz="1400">
+                <a:solidFill>
+                  <a:srgbClr val="333333"/>
+                </a:solidFill>
+                <a:latin typeface="Consolas"/>
+              </a:rPr>
+              <a:t>    double r;</a:t>
+            </a:r>
+          </a:p>
+          <a:p>
+            <a:r>
+              <a:rPr sz="1400">
+                <a:solidFill>
+                  <a:srgbClr val="333333"/>
+                </a:solidFill>
+                <a:latin typeface="Consolas"/>
+              </a:rPr>
+              <a:t>    cin &gt;&gt; r;</a:t>
+            </a:r>
+          </a:p>
+          <a:p>
+            <a:r>
+              <a:rPr sz="1400">
+                <a:solidFill>
+                  <a:srgbClr val="333333"/>
+                </a:solidFill>
+                <a:latin typeface="Consolas"/>
+              </a:rPr>
+              <a:t>    double diameter = 2 * r;</a:t>
+            </a:r>
+          </a:p>
+          <a:p>
+            <a:r>
+              <a:rPr sz="1400">
+                <a:solidFill>
+                  <a:srgbClr val="333333"/>
+                </a:solidFill>
+                <a:latin typeface="Consolas"/>
+              </a:rPr>
+              <a:t>    double circumference = 2 * M_PI * r;</a:t>
+            </a:r>
+          </a:p>
+          <a:p>
+            <a:r>
+              <a:rPr sz="1400">
+                <a:solidFill>
+                  <a:srgbClr val="333333"/>
+                </a:solidFill>
+                <a:latin typeface="Consolas"/>
+              </a:rPr>
+              <a:t>    double area = M_PI * r * r;</a:t>
+            </a:r>
+          </a:p>
+          <a:p>
+            <a:r>
+              <a:rPr sz="1400">
+                <a:solidFill>
+                  <a:srgbClr val="333333"/>
+                </a:solidFill>
+                <a:latin typeface="Consolas"/>
+              </a:rPr>
+              <a:t>    cout &lt;&lt; "Diameter: " &lt;&lt; diameter &lt;&lt; endl;</a:t>
+            </a:r>
+          </a:p>
+          <a:p>
+            <a:r>
+              <a:rPr sz="1400">
+                <a:solidFill>
+                  <a:srgbClr val="333333"/>
+                </a:solidFill>
+                <a:latin typeface="Consolas"/>
+              </a:rPr>
+              <a:t>    cout &lt;&lt; "Circumference: " &lt;&lt; circumference &lt;&lt; endl;</a:t>
+            </a:r>
+          </a:p>
+          <a:p>
+            <a:r>
+              <a:rPr sz="1400">
+                <a:solidFill>
+                  <a:srgbClr val="333333"/>
+                </a:solidFill>
+                <a:latin typeface="Consolas"/>
+              </a:rPr>
+              <a:t>    cout &lt;&lt; "Area: " &lt;&lt; area &lt;&lt; endl;</a:t>
+            </a:r>
+          </a:p>
+          <a:p>
+            <a:r>
+              <a:rPr sz="1400">
+                <a:solidFill>
+                  <a:srgbClr val="333333"/>
+                </a:solidFill>
+                <a:latin typeface="Consolas"/>
+              </a:rPr>
+              <a:t>    return 0;</a:t>
+            </a:r>
+          </a:p>
+          <a:p>
+            <a:r>
+              <a:rPr sz="1400">
+                <a:solidFill>
+                  <a:srgbClr val="333333"/>
+                </a:solidFill>
+                <a:latin typeface="Consolas"/>
+              </a:rPr>
+              <a:t>}</a:t>
+            </a:r>
+          </a:p>
+        </p:txBody>
+      </p:sp>
+      <p:sp>
+        <p:nvSpPr>
+          <p:cNvPr id="6" name="TextBox 5"/>
           <p:cNvSpPr txBox="1"/>
           <p:nvPr/>
         </p:nvSpPr>
@@ -4089,7 +6022,7 @@
                   <a:srgbClr val="999999"/>
                 </a:solidFill>
               </a:rPr>
-              <a:t>演算法之美/練習1.cpp</a:t>
+              <a:t>c++ 基礎知識/練習1.cpp</a:t>
             </a:r>
           </a:p>
         </p:txBody>
@@ -4140,7 +6073,7 @@
                   <a:srgbClr val="1F3B57"/>
                 </a:solidFill>
               </a:rPr>
-              <a:t>原始版本：固定大小陣列的風險</a:t>
+              <a:t>c++ 基礎知識 — 練習2</a:t>
             </a:r>
           </a:p>
         </p:txBody>
@@ -4197,8 +6130,41 @@
         </p:nvSpPr>
         <p:spPr>
           <a:xfrm>
-            <a:off x="548640" y="1554480"/>
-            <a:ext cx="6400800" cy="2743200"/>
+            <a:off x="548640" y="1371600"/>
+            <a:ext cx="11064240" cy="640080"/>
+          </a:xfrm>
+          <a:prstGeom prst="rect">
+            <a:avLst/>
+          </a:prstGeom>
+          <a:noFill/>
+        </p:spPr>
+        <p:txBody>
+          <a:bodyPr wrap="square">
+            <a:spAutoFit/>
+          </a:bodyPr>
+          <a:lstStyle/>
+          <a:p>
+            <a:r>
+              <a:rPr sz="1800">
+                <a:solidFill>
+                  <a:srgbClr val="2B2B2B"/>
+                </a:solidFill>
+              </a:rPr>
+              <a:t>給定三條線段的長度(正整數)，判斷能否構成三角形</a:t>
+            </a:r>
+          </a:p>
+        </p:txBody>
+      </p:sp>
+      <p:sp>
+        <p:nvSpPr>
+          <p:cNvPr id="5" name="TextBox 4"/>
+          <p:cNvSpPr txBox="1"/>
+          <p:nvPr/>
+        </p:nvSpPr>
+        <p:spPr>
+          <a:xfrm>
+            <a:off x="548640" y="2103120"/>
+            <a:ext cx="11064240" cy="4114800"/>
           </a:xfrm>
           <a:prstGeom prst="rect">
             <a:avLst/>
@@ -4219,73 +6185,95 @@
           <a:lstStyle/>
           <a:p>
             <a:r>
-              <a:rPr sz="1600">
-                <a:solidFill>
-                  <a:srgbClr val="333333"/>
-                </a:solidFill>
-                <a:latin typeface="Consolas"/>
-              </a:rPr>
-              <a:t>int ans[1000];</a:t>
-            </a:r>
-          </a:p>
-          <a:p>
-            <a:r>
-              <a:rPr sz="1600">
-                <a:solidFill>
-                  <a:srgbClr val="333333"/>
-                </a:solidFill>
-                <a:latin typeface="Consolas"/>
-              </a:rPr>
-              <a:t/>
-            </a:r>
-          </a:p>
-          <a:p>
-            <a:r>
-              <a:rPr sz="1600">
-                <a:solidFill>
-                  <a:srgbClr val="333333"/>
-                </a:solidFill>
-                <a:latin typeface="Consolas"/>
-              </a:rPr>
-              <a:t>for (int i = x; i &lt;= y; i++) {</a:t>
-            </a:r>
-          </a:p>
-          <a:p>
-            <a:r>
-              <a:rPr sz="1600">
-                <a:solidFill>
-                  <a:srgbClr val="333333"/>
-                </a:solidFill>
-                <a:latin typeface="Consolas"/>
-              </a:rPr>
-              <a:t>    if (judge(i)) {</a:t>
-            </a:r>
-          </a:p>
-          <a:p>
-            <a:r>
-              <a:rPr sz="1600">
-                <a:solidFill>
-                  <a:srgbClr val="333333"/>
-                </a:solidFill>
-                <a:latin typeface="Consolas"/>
-              </a:rPr>
-              <a:t>        ans[cnt++] = i;   // cnt 超過 1000 就會越界！</a:t>
-            </a:r>
-          </a:p>
-          <a:p>
-            <a:r>
-              <a:rPr sz="1600">
-                <a:solidFill>
-                  <a:srgbClr val="333333"/>
-                </a:solidFill>
-                <a:latin typeface="Consolas"/>
-              </a:rPr>
-              <a:t>    }</a:t>
-            </a:r>
-          </a:p>
-          <a:p>
-            <a:r>
-              <a:rPr sz="1600">
+              <a:rPr sz="1400">
+                <a:solidFill>
+                  <a:srgbClr val="333333"/>
+                </a:solidFill>
+                <a:latin typeface="Consolas"/>
+              </a:rPr>
+              <a:t>int main() {</a:t>
+            </a:r>
+          </a:p>
+          <a:p>
+            <a:r>
+              <a:rPr sz="1400">
+                <a:solidFill>
+                  <a:srgbClr val="333333"/>
+                </a:solidFill>
+                <a:latin typeface="Consolas"/>
+              </a:rPr>
+              <a:t>    int a,b,c;</a:t>
+            </a:r>
+          </a:p>
+          <a:p>
+            <a:r>
+              <a:rPr sz="1400">
+                <a:solidFill>
+                  <a:srgbClr val="333333"/>
+                </a:solidFill>
+                <a:latin typeface="Consolas"/>
+              </a:rPr>
+              <a:t>    cin&gt;&gt;a&gt;&gt;b&gt;&gt;c;</a:t>
+            </a:r>
+          </a:p>
+          <a:p>
+            <a:r>
+              <a:rPr sz="1400">
+                <a:solidFill>
+                  <a:srgbClr val="333333"/>
+                </a:solidFill>
+                <a:latin typeface="Consolas"/>
+              </a:rPr>
+              <a:t>    if(a+b&gt;c &amp;&amp; a+c&gt;b &amp;&amp; b+c&gt;a)</a:t>
+            </a:r>
+          </a:p>
+          <a:p>
+            <a:r>
+              <a:rPr sz="1400">
+                <a:solidFill>
+                  <a:srgbClr val="333333"/>
+                </a:solidFill>
+                <a:latin typeface="Consolas"/>
+              </a:rPr>
+              <a:t>        cout&lt;&lt;"Yes"&lt;&lt;endl;</a:t>
+            </a:r>
+          </a:p>
+          <a:p>
+            <a:r>
+              <a:rPr sz="1400">
+                <a:solidFill>
+                  <a:srgbClr val="333333"/>
+                </a:solidFill>
+                <a:latin typeface="Consolas"/>
+              </a:rPr>
+              <a:t>    else</a:t>
+            </a:r>
+          </a:p>
+          <a:p>
+            <a:r>
+              <a:rPr sz="1400">
+                <a:solidFill>
+                  <a:srgbClr val="333333"/>
+                </a:solidFill>
+                <a:latin typeface="Consolas"/>
+              </a:rPr>
+              <a:t>        cout&lt;&lt;"No"&lt;&lt;endl;</a:t>
+            </a:r>
+          </a:p>
+          <a:p>
+            <a:r>
+              <a:rPr sz="1400">
+                <a:solidFill>
+                  <a:srgbClr val="333333"/>
+                </a:solidFill>
+                <a:latin typeface="Consolas"/>
+              </a:rPr>
+              <a:t>    return 0;</a:t>
+            </a:r>
+          </a:p>
+          <a:p>
+            <a:r>
+              <a:rPr sz="1400">
                 <a:solidFill>
                   <a:srgbClr val="333333"/>
                 </a:solidFill>
@@ -4298,14 +6286,14 @@
       </p:sp>
       <p:sp>
         <p:nvSpPr>
-          <p:cNvPr id="5" name="TextBox 4"/>
+          <p:cNvPr id="6" name="TextBox 5"/>
           <p:cNvSpPr txBox="1"/>
           <p:nvPr/>
         </p:nvSpPr>
         <p:spPr>
           <a:xfrm>
-            <a:off x="7223760" y="1554480"/>
-            <a:ext cx="4480560" cy="4389120"/>
+            <a:off x="548640" y="6446520"/>
+            <a:ext cx="11064240" cy="320040"/>
           </a:xfrm>
           <a:prstGeom prst="rect">
             <a:avLst/>
@@ -4313,104 +6301,6 @@
           <a:noFill/>
         </p:spPr>
         <p:txBody>
-          <a:bodyPr wrap="square">
-            <a:spAutoFit/>
-          </a:bodyPr>
-          <a:lstStyle/>
-          <a:p>
-            <a:pPr>
-              <a:spcAft>
-                <a:spcPts val="1000"/>
-              </a:spcAft>
-            </a:pPr>
-            <a:r>
-              <a:rPr sz="1600">
-                <a:solidFill>
-                  <a:srgbClr val="2B2B2B"/>
-                </a:solidFill>
-              </a:rPr>
-              <a:t>問題點：</a:t>
-            </a:r>
-          </a:p>
-          <a:p>
-            <a:pPr lvl="1">
-              <a:spcAft>
-                <a:spcPts val="1000"/>
-              </a:spcAft>
-            </a:pPr>
-            <a:r>
-              <a:rPr sz="1400">
-                <a:solidFill>
-                  <a:srgbClr val="2B2B2B"/>
-                </a:solidFill>
-              </a:rPr>
-              <a:t>陣列大小 1000 是憑經驗猜測的上限</a:t>
-            </a:r>
-          </a:p>
-          <a:p>
-            <a:pPr lvl="1">
-              <a:spcAft>
-                <a:spcPts val="1000"/>
-              </a:spcAft>
-            </a:pPr>
-            <a:r>
-              <a:rPr sz="1400">
-                <a:solidFill>
-                  <a:srgbClr val="2B2B2B"/>
-                </a:solidFill>
-              </a:rPr>
-              <a:t>若 [x, y] 區間夠大（例如 x=1, y=1000000），閏年數量會遠超過 1000</a:t>
-            </a:r>
-          </a:p>
-          <a:p>
-            <a:pPr lvl="1">
-              <a:spcAft>
-                <a:spcPts val="1000"/>
-              </a:spcAft>
-            </a:pPr>
-            <a:r>
-              <a:rPr sz="1400">
-                <a:solidFill>
-                  <a:srgbClr val="2B2B2B"/>
-                </a:solidFill>
-              </a:rPr>
-              <a:t>超出陣列邊界寫入 = 未定義行為（Undefined Behavior）</a:t>
-            </a:r>
-          </a:p>
-          <a:p>
-            <a:pPr lvl="1">
-              <a:spcAft>
-                <a:spcPts val="1000"/>
-              </a:spcAft>
-            </a:pPr>
-            <a:r>
-              <a:rPr sz="1400">
-                <a:solidFill>
-                  <a:srgbClr val="2B2B2B"/>
-                </a:solidFill>
-              </a:rPr>
-              <a:t>可能導致資料損毀、程式崩潰，且不易察覺、難以除錯</a:t>
-            </a:r>
-          </a:p>
-        </p:txBody>
-      </p:sp>
-      <p:sp>
-        <p:nvSpPr>
-          <p:cNvPr id="6" name="TextBox 5"/>
-          <p:cNvSpPr txBox="1"/>
-          <p:nvPr/>
-        </p:nvSpPr>
-        <p:spPr>
-          <a:xfrm>
-            <a:off x="548640" y="6446520"/>
-            <a:ext cx="11064240" cy="320040"/>
-          </a:xfrm>
-          <a:prstGeom prst="rect">
-            <a:avLst/>
-          </a:prstGeom>
-          <a:noFill/>
-        </p:spPr>
-        <p:txBody>
           <a:bodyPr wrap="none">
             <a:spAutoFit/>
           </a:bodyPr>
@@ -4422,7 +6312,7 @@
                   <a:srgbClr val="999999"/>
                 </a:solidFill>
               </a:rPr>
-              <a:t>演算法之美/練習1.cpp</a:t>
+              <a:t>c++ 基礎知識/練習2.cpp</a:t>
             </a:r>
           </a:p>
         </p:txBody>
@@ -4473,7 +6363,7 @@
                   <a:srgbClr val="1F3B57"/>
                 </a:solidFill>
               </a:rPr>
-              <a:t>改進版本：std::vector 動態陣列</a:t>
+              <a:t>c++ 基礎知識 — 練習3</a:t>
             </a:r>
           </a:p>
         </p:txBody>
@@ -4530,8 +6420,41 @@
         </p:nvSpPr>
         <p:spPr>
           <a:xfrm>
-            <a:off x="548640" y="1554480"/>
-            <a:ext cx="6400800" cy="3291840"/>
+            <a:off x="548640" y="1371600"/>
+            <a:ext cx="11064240" cy="640080"/>
+          </a:xfrm>
+          <a:prstGeom prst="rect">
+            <a:avLst/>
+          </a:prstGeom>
+          <a:noFill/>
+        </p:spPr>
+        <p:txBody>
+          <a:bodyPr wrap="square">
+            <a:spAutoFit/>
+          </a:bodyPr>
+          <a:lstStyle/>
+          <a:p>
+            <a:r>
+              <a:rPr sz="1800">
+                <a:solidFill>
+                  <a:srgbClr val="2B2B2B"/>
+                </a:solidFill>
+              </a:rPr>
+              <a:t>給定一個整數 n，判斷是奇數還是偶數，輸出 Odd / Even</a:t>
+            </a:r>
+          </a:p>
+        </p:txBody>
+      </p:sp>
+      <p:sp>
+        <p:nvSpPr>
+          <p:cNvPr id="5" name="TextBox 4"/>
+          <p:cNvSpPr txBox="1"/>
+          <p:nvPr/>
+        </p:nvSpPr>
+        <p:spPr>
+          <a:xfrm>
+            <a:off x="548640" y="2103120"/>
+            <a:ext cx="11064240" cy="4114800"/>
           </a:xfrm>
           <a:prstGeom prst="rect">
             <a:avLst/>
@@ -4552,73 +6475,95 @@
           <a:lstStyle/>
           <a:p>
             <a:r>
-              <a:rPr sz="1500">
-                <a:solidFill>
-                  <a:srgbClr val="333333"/>
-                </a:solidFill>
-                <a:latin typeface="Consolas"/>
-              </a:rPr>
-              <a:t>vector&lt;int&gt; ans;   // 不用事先宣告大小</a:t>
-            </a:r>
-          </a:p>
-          <a:p>
-            <a:r>
-              <a:rPr sz="1500">
-                <a:solidFill>
-                  <a:srgbClr val="333333"/>
-                </a:solidFill>
-                <a:latin typeface="Consolas"/>
-              </a:rPr>
-              <a:t/>
-            </a:r>
-          </a:p>
-          <a:p>
-            <a:r>
-              <a:rPr sz="1500">
-                <a:solidFill>
-                  <a:srgbClr val="333333"/>
-                </a:solidFill>
-                <a:latin typeface="Consolas"/>
-              </a:rPr>
-              <a:t>for (int i = x; i &lt;= y; i++) {</a:t>
-            </a:r>
-          </a:p>
-          <a:p>
-            <a:r>
-              <a:rPr sz="1500">
-                <a:solidFill>
-                  <a:srgbClr val="333333"/>
-                </a:solidFill>
-                <a:latin typeface="Consolas"/>
-              </a:rPr>
-              <a:t>    if (judge(i)) {</a:t>
-            </a:r>
-          </a:p>
-          <a:p>
-            <a:r>
-              <a:rPr sz="1500">
-                <a:solidFill>
-                  <a:srgbClr val="333333"/>
-                </a:solidFill>
-                <a:latin typeface="Consolas"/>
-              </a:rPr>
-              <a:t>        ans.push_back(i);   // 自動成長，不會越界</a:t>
-            </a:r>
-          </a:p>
-          <a:p>
-            <a:r>
-              <a:rPr sz="1500">
-                <a:solidFill>
-                  <a:srgbClr val="333333"/>
-                </a:solidFill>
-                <a:latin typeface="Consolas"/>
-              </a:rPr>
-              <a:t>    }</a:t>
-            </a:r>
-          </a:p>
-          <a:p>
-            <a:r>
-              <a:rPr sz="1500">
+              <a:rPr sz="1400">
+                <a:solidFill>
+                  <a:srgbClr val="333333"/>
+                </a:solidFill>
+                <a:latin typeface="Consolas"/>
+              </a:rPr>
+              <a:t>int main() {</a:t>
+            </a:r>
+          </a:p>
+          <a:p>
+            <a:r>
+              <a:rPr sz="1400">
+                <a:solidFill>
+                  <a:srgbClr val="333333"/>
+                </a:solidFill>
+                <a:latin typeface="Consolas"/>
+              </a:rPr>
+              <a:t>    int n;</a:t>
+            </a:r>
+          </a:p>
+          <a:p>
+            <a:r>
+              <a:rPr sz="1400">
+                <a:solidFill>
+                  <a:srgbClr val="333333"/>
+                </a:solidFill>
+                <a:latin typeface="Consolas"/>
+              </a:rPr>
+              <a:t>    cin&gt;&gt;n;</a:t>
+            </a:r>
+          </a:p>
+          <a:p>
+            <a:r>
+              <a:rPr sz="1400">
+                <a:solidFill>
+                  <a:srgbClr val="333333"/>
+                </a:solidFill>
+                <a:latin typeface="Consolas"/>
+              </a:rPr>
+              <a:t>    if(n%2)</a:t>
+            </a:r>
+          </a:p>
+          <a:p>
+            <a:r>
+              <a:rPr sz="1400">
+                <a:solidFill>
+                  <a:srgbClr val="333333"/>
+                </a:solidFill>
+                <a:latin typeface="Consolas"/>
+              </a:rPr>
+              <a:t>        cout&lt;&lt;"Odd"&lt;&lt;endl;</a:t>
+            </a:r>
+          </a:p>
+          <a:p>
+            <a:r>
+              <a:rPr sz="1400">
+                <a:solidFill>
+                  <a:srgbClr val="333333"/>
+                </a:solidFill>
+                <a:latin typeface="Consolas"/>
+              </a:rPr>
+              <a:t>    else</a:t>
+            </a:r>
+          </a:p>
+          <a:p>
+            <a:r>
+              <a:rPr sz="1400">
+                <a:solidFill>
+                  <a:srgbClr val="333333"/>
+                </a:solidFill>
+                <a:latin typeface="Consolas"/>
+              </a:rPr>
+              <a:t>        cout&lt;&lt;"Even"&lt;&lt;endl;</a:t>
+            </a:r>
+          </a:p>
+          <a:p>
+            <a:r>
+              <a:rPr sz="1400">
+                <a:solidFill>
+                  <a:srgbClr val="333333"/>
+                </a:solidFill>
+                <a:latin typeface="Consolas"/>
+              </a:rPr>
+              <a:t>    return 0;</a:t>
+            </a:r>
+          </a:p>
+          <a:p>
+            <a:r>
+              <a:rPr sz="1400">
                 <a:solidFill>
                   <a:srgbClr val="333333"/>
                 </a:solidFill>
@@ -4627,51 +6572,18 @@
               <a:t>}</a:t>
             </a:r>
           </a:p>
-          <a:p>
-            <a:r>
-              <a:rPr sz="1500">
-                <a:solidFill>
-                  <a:srgbClr val="333333"/>
-                </a:solidFill>
-                <a:latin typeface="Consolas"/>
-              </a:rPr>
-              <a:t/>
-            </a:r>
-          </a:p>
-          <a:p>
-            <a:r>
-              <a:rPr sz="1500">
-                <a:solidFill>
-                  <a:srgbClr val="333333"/>
-                </a:solidFill>
-                <a:latin typeface="Consolas"/>
-              </a:rPr>
-              <a:t>cout &lt;&lt; ans.size() &lt;&lt; endl;</a:t>
-            </a:r>
-          </a:p>
-          <a:p>
-            <a:r>
-              <a:rPr sz="1500">
-                <a:solidFill>
-                  <a:srgbClr val="333333"/>
-                </a:solidFill>
-                <a:latin typeface="Consolas"/>
-              </a:rPr>
-              <a:t>for (int v : ans) cout &lt;&lt; v &lt;&lt; " ";</a:t>
-            </a:r>
-          </a:p>
-        </p:txBody>
-      </p:sp>
-      <p:sp>
-        <p:nvSpPr>
-          <p:cNvPr id="5" name="TextBox 4"/>
+        </p:txBody>
+      </p:sp>
+      <p:sp>
+        <p:nvSpPr>
+          <p:cNvPr id="6" name="TextBox 5"/>
           <p:cNvSpPr txBox="1"/>
           <p:nvPr/>
         </p:nvSpPr>
         <p:spPr>
           <a:xfrm>
-            <a:off x="7223760" y="1554480"/>
-            <a:ext cx="4480560" cy="4389120"/>
+            <a:off x="548640" y="6446520"/>
+            <a:ext cx="11064240" cy="320040"/>
           </a:xfrm>
           <a:prstGeom prst="rect">
             <a:avLst/>
@@ -4679,104 +6591,6 @@
           <a:noFill/>
         </p:spPr>
         <p:txBody>
-          <a:bodyPr wrap="square">
-            <a:spAutoFit/>
-          </a:bodyPr>
-          <a:lstStyle/>
-          <a:p>
-            <a:pPr>
-              <a:spcAft>
-                <a:spcPts val="1000"/>
-              </a:spcAft>
-            </a:pPr>
-            <a:r>
-              <a:rPr sz="1600">
-                <a:solidFill>
-                  <a:srgbClr val="2B2B2B"/>
-                </a:solidFill>
-              </a:rPr>
-              <a:t>改進效果：</a:t>
-            </a:r>
-          </a:p>
-          <a:p>
-            <a:pPr lvl="1">
-              <a:spcAft>
-                <a:spcPts val="1000"/>
-              </a:spcAft>
-            </a:pPr>
-            <a:r>
-              <a:rPr sz="1400">
-                <a:solidFill>
-                  <a:srgbClr val="2B2B2B"/>
-                </a:solidFill>
-              </a:rPr>
-              <a:t>容量隨資料動態成長，無需事先猜測上限</a:t>
-            </a:r>
-          </a:p>
-          <a:p>
-            <a:pPr lvl="1">
-              <a:spcAft>
-                <a:spcPts val="1000"/>
-              </a:spcAft>
-            </a:pPr>
-            <a:r>
-              <a:rPr sz="1400">
-                <a:solidFill>
-                  <a:srgbClr val="2B2B2B"/>
-                </a:solidFill>
-              </a:rPr>
-              <a:t>消除陣列越界的未定義行為風險</a:t>
-            </a:r>
-          </a:p>
-          <a:p>
-            <a:pPr lvl="1">
-              <a:spcAft>
-                <a:spcPts val="1000"/>
-              </a:spcAft>
-            </a:pPr>
-            <a:r>
-              <a:rPr sz="1400">
-                <a:solidFill>
-                  <a:srgbClr val="2B2B2B"/>
-                </a:solidFill>
-              </a:rPr>
-              <a:t>程式碼更貼近「資料多大就存多大」的直覺</a:t>
-            </a:r>
-          </a:p>
-          <a:p>
-            <a:pPr lvl="1">
-              <a:spcAft>
-                <a:spcPts val="1000"/>
-              </a:spcAft>
-            </a:pPr>
-            <a:r>
-              <a:rPr sz="1400">
-                <a:solidFill>
-                  <a:srgbClr val="2B2B2B"/>
-                </a:solidFill>
-              </a:rPr>
-              <a:t>檔案：演算法之美/練習1-adviced.cpp</a:t>
-            </a:r>
-          </a:p>
-        </p:txBody>
-      </p:sp>
-      <p:sp>
-        <p:nvSpPr>
-          <p:cNvPr id="6" name="TextBox 5"/>
-          <p:cNvSpPr txBox="1"/>
-          <p:nvPr/>
-        </p:nvSpPr>
-        <p:spPr>
-          <a:xfrm>
-            <a:off x="548640" y="6446520"/>
-            <a:ext cx="11064240" cy="320040"/>
-          </a:xfrm>
-          <a:prstGeom prst="rect">
-            <a:avLst/>
-          </a:prstGeom>
-          <a:noFill/>
-        </p:spPr>
-        <p:txBody>
           <a:bodyPr wrap="none">
             <a:spAutoFit/>
           </a:bodyPr>
@@ -4788,7 +6602,7 @@
                   <a:srgbClr val="999999"/>
                 </a:solidFill>
               </a:rPr>
-              <a:t>演算法之美/練習1-adviced.cpp</a:t>
+              <a:t>c++ 基礎知識/練習3.cpp</a:t>
             </a:r>
           </a:p>
         </p:txBody>
@@ -4834,12 +6648,12 @@
           <a:lstStyle/>
           <a:p>
             <a:r>
-              <a:rPr sz="3600" b="1">
+              <a:rPr sz="3200" b="1">
                 <a:solidFill>
                   <a:srgbClr val="1F3B57"/>
                 </a:solidFill>
               </a:rPr>
-              <a:t>改進前後對照</a:t>
+              <a:t>c++ 基礎知識 — 練習4</a:t>
             </a:r>
           </a:p>
         </p:txBody>
@@ -4888,291 +6702,16 @@
           </a:p>
         </p:txBody>
       </p:sp>
-      <p:graphicFrame>
-        <p:nvGraphicFramePr>
-          <p:cNvPr id="4" name="Table 3"/>
-          <p:cNvGraphicFramePr>
-            <a:graphicFrameLocks noGrp="1"/>
-          </p:cNvGraphicFramePr>
-          <p:nvPr/>
-        </p:nvGraphicFramePr>
-        <p:xfrm>
-          <a:off x="548640" y="1554480"/>
-          <a:ext cx="11064240" cy="4023360"/>
-        </p:xfrm>
-        <a:graphic>
-          <a:graphicData uri="http://schemas.openxmlformats.org/drawingml/2006/table">
-            <a:tbl>
-              <a:tblPr firstRow="1" bandRow="1">
-                <a:tableStyleId>{5C22544A-7EE6-4342-B048-85BDC9FD1C3A}</a:tableStyleId>
-              </a:tblPr>
-              <a:tblGrid>
-                <a:gridCol w="2377440"/>
-                <a:gridCol w="4343400"/>
-                <a:gridCol w="4343400"/>
-              </a:tblGrid>
-              <a:tr h="1005840">
-                <a:tc>
-                  <a:txBody>
-                    <a:bodyPr/>
-                    <a:lstStyle/>
-                    <a:p>
-                      <a:pPr>
-                        <a:defRPr b="1" sz="1600">
-                          <a:solidFill>
-                            <a:srgbClr val="FFFFFF"/>
-                          </a:solidFill>
-                        </a:defRPr>
-                      </a:pPr>
-                      <a:r>
-                        <a:t>項目</a:t>
-                      </a:r>
-                    </a:p>
-                  </a:txBody>
-                  <a:tcPr>
-                    <a:solidFill>
-                      <a:srgbClr val="2E86AB"/>
-                    </a:solidFill>
-                  </a:tcPr>
-                </a:tc>
-                <a:tc>
-                  <a:txBody>
-                    <a:bodyPr/>
-                    <a:lstStyle/>
-                    <a:p>
-                      <a:pPr>
-                        <a:defRPr b="1" sz="1600">
-                          <a:solidFill>
-                            <a:srgbClr val="FFFFFF"/>
-                          </a:solidFill>
-                        </a:defRPr>
-                      </a:pPr>
-                      <a:r>
-                        <a:t>原版 練習1.cpp</a:t>
-                      </a:r>
-                    </a:p>
-                  </a:txBody>
-                  <a:tcPr>
-                    <a:solidFill>
-                      <a:srgbClr val="2E86AB"/>
-                    </a:solidFill>
-                  </a:tcPr>
-                </a:tc>
-                <a:tc>
-                  <a:txBody>
-                    <a:bodyPr/>
-                    <a:lstStyle/>
-                    <a:p>
-                      <a:pPr>
-                        <a:defRPr b="1" sz="1600">
-                          <a:solidFill>
-                            <a:srgbClr val="FFFFFF"/>
-                          </a:solidFill>
-                        </a:defRPr>
-                      </a:pPr>
-                      <a:r>
-                        <a:t>改進版 練習1-adviced.cpp</a:t>
-                      </a:r>
-                    </a:p>
-                  </a:txBody>
-                  <a:tcPr>
-                    <a:solidFill>
-                      <a:srgbClr val="2E86AB"/>
-                    </a:solidFill>
-                  </a:tcPr>
-                </a:tc>
-              </a:tr>
-              <a:tr h="1005840">
-                <a:tc>
-                  <a:txBody>
-                    <a:bodyPr/>
-                    <a:lstStyle/>
-                    <a:p>
-                      <a:pPr>
-                        <a:defRPr sz="1400">
-                          <a:solidFill>
-                            <a:srgbClr val="2B2B2B"/>
-                          </a:solidFill>
-                        </a:defRPr>
-                      </a:pPr>
-                      <a:r>
-                        <a:t>資料結構</a:t>
-                      </a:r>
-                    </a:p>
-                  </a:txBody>
-                  <a:tcPr/>
-                </a:tc>
-                <a:tc>
-                  <a:txBody>
-                    <a:bodyPr/>
-                    <a:lstStyle/>
-                    <a:p>
-                      <a:pPr>
-                        <a:defRPr sz="1400">
-                          <a:solidFill>
-                            <a:srgbClr val="2B2B2B"/>
-                          </a:solidFill>
-                        </a:defRPr>
-                      </a:pPr>
-                      <a:r>
-                        <a:t>int ans[1000]（固定大小全域陣列）</a:t>
-                      </a:r>
-                    </a:p>
-                  </a:txBody>
-                  <a:tcPr/>
-                </a:tc>
-                <a:tc>
-                  <a:txBody>
-                    <a:bodyPr/>
-                    <a:lstStyle/>
-                    <a:p>
-                      <a:pPr>
-                        <a:defRPr sz="1400">
-                          <a:solidFill>
-                            <a:srgbClr val="2B2B2B"/>
-                          </a:solidFill>
-                        </a:defRPr>
-                      </a:pPr>
-                      <a:r>
-                        <a:t>std::vector&lt;int&gt;（動態陣列）</a:t>
-                      </a:r>
-                    </a:p>
-                  </a:txBody>
-                  <a:tcPr/>
-                </a:tc>
-              </a:tr>
-              <a:tr h="1005840">
-                <a:tc>
-                  <a:txBody>
-                    <a:bodyPr/>
-                    <a:lstStyle/>
-                    <a:p>
-                      <a:pPr>
-                        <a:defRPr sz="1400">
-                          <a:solidFill>
-                            <a:srgbClr val="2B2B2B"/>
-                          </a:solidFill>
-                        </a:defRPr>
-                      </a:pPr>
-                      <a:r>
-                        <a:t>容量上限</a:t>
-                      </a:r>
-                    </a:p>
-                  </a:txBody>
-                  <a:tcPr/>
-                </a:tc>
-                <a:tc>
-                  <a:txBody>
-                    <a:bodyPr/>
-                    <a:lstStyle/>
-                    <a:p>
-                      <a:pPr>
-                        <a:defRPr sz="1400">
-                          <a:solidFill>
-                            <a:srgbClr val="2B2B2B"/>
-                          </a:solidFill>
-                        </a:defRPr>
-                      </a:pPr>
-                      <a:r>
-                        <a:t>需事先猜測，寫死 1000</a:t>
-                      </a:r>
-                    </a:p>
-                  </a:txBody>
-                  <a:tcPr/>
-                </a:tc>
-                <a:tc>
-                  <a:txBody>
-                    <a:bodyPr/>
-                    <a:lstStyle/>
-                    <a:p>
-                      <a:pPr>
-                        <a:defRPr sz="1400">
-                          <a:solidFill>
-                            <a:srgbClr val="2B2B2B"/>
-                          </a:solidFill>
-                        </a:defRPr>
-                      </a:pPr>
-                      <a:r>
-                        <a:t>無需猜測，隨資料自動成長</a:t>
-                      </a:r>
-                    </a:p>
-                  </a:txBody>
-                  <a:tcPr/>
-                </a:tc>
-              </a:tr>
-              <a:tr h="1005840">
-                <a:tc>
-                  <a:txBody>
-                    <a:bodyPr/>
-                    <a:lstStyle/>
-                    <a:p>
-                      <a:pPr>
-                        <a:defRPr sz="1400">
-                          <a:solidFill>
-                            <a:srgbClr val="2B2B2B"/>
-                          </a:solidFill>
-                        </a:defRPr>
-                      </a:pPr>
-                      <a:r>
-                        <a:t>風險</a:t>
-                      </a:r>
-                    </a:p>
-                  </a:txBody>
-                  <a:tcPr/>
-                </a:tc>
-                <a:tc>
-                  <a:txBody>
-                    <a:bodyPr/>
-                    <a:lstStyle/>
-                    <a:p>
-                      <a:pPr>
-                        <a:defRPr sz="1400">
-                          <a:solidFill>
-                            <a:srgbClr val="2B2B2B"/>
-                          </a:solidFill>
-                        </a:defRPr>
-                      </a:pPr>
-                      <a:r>
-                        <a:t>超出 1000 筆時越界，UB</a:t>
-                      </a:r>
-                    </a:p>
-                  </a:txBody>
-                  <a:tcPr/>
-                </a:tc>
-                <a:tc>
-                  <a:txBody>
-                    <a:bodyPr/>
-                    <a:lstStyle/>
-                    <a:p>
-                      <a:pPr>
-                        <a:defRPr sz="1400">
-                          <a:solidFill>
-                            <a:srgbClr val="2B2B2B"/>
-                          </a:solidFill>
-                        </a:defRPr>
-                      </a:pPr>
-                      <a:r>
-                        <a:t>無越界風險</a:t>
-                      </a:r>
-                    </a:p>
-                  </a:txBody>
-                  <a:tcPr/>
-                </a:tc>
-              </a:tr>
-            </a:tbl>
-          </a:graphicData>
-        </a:graphic>
-      </p:graphicFrame>
-      <p:sp>
-        <p:nvSpPr>
-          <p:cNvPr id="5" name="TextBox 4"/>
+      <p:sp>
+        <p:nvSpPr>
+          <p:cNvPr id="4" name="TextBox 3"/>
           <p:cNvSpPr txBox="1"/>
           <p:nvPr/>
         </p:nvSpPr>
         <p:spPr>
           <a:xfrm>
-            <a:off x="548640" y="6446520"/>
-            <a:ext cx="11064240" cy="320040"/>
+            <a:off x="548640" y="1371600"/>
+            <a:ext cx="11064240" cy="640080"/>
           </a:xfrm>
           <a:prstGeom prst="rect">
             <a:avLst/>
@@ -5180,6 +6719,168 @@
           <a:noFill/>
         </p:spPr>
         <p:txBody>
+          <a:bodyPr wrap="square">
+            <a:spAutoFit/>
+          </a:bodyPr>
+          <a:lstStyle/>
+          <a:p>
+            <a:r>
+              <a:rPr sz="1800">
+                <a:solidFill>
+                  <a:srgbClr val="2B2B2B"/>
+                </a:solidFill>
+              </a:rPr>
+              <a:t>給定一個年份 year，判斷是否為閏年，是輸出 1，否則輸出 0</a:t>
+            </a:r>
+          </a:p>
+        </p:txBody>
+      </p:sp>
+      <p:sp>
+        <p:nvSpPr>
+          <p:cNvPr id="5" name="TextBox 4"/>
+          <p:cNvSpPr txBox="1"/>
+          <p:nvPr/>
+        </p:nvSpPr>
+        <p:spPr>
+          <a:xfrm>
+            <a:off x="548640" y="2103120"/>
+            <a:ext cx="11064240" cy="4114800"/>
+          </a:xfrm>
+          <a:prstGeom prst="rect">
+            <a:avLst/>
+          </a:prstGeom>
+          <a:solidFill>
+            <a:srgbClr val="F4F4F4"/>
+          </a:solidFill>
+          <a:ln w="9525">
+            <a:solidFill>
+              <a:srgbClr val="D0D0D0"/>
+            </a:solidFill>
+          </a:ln>
+        </p:spPr>
+        <p:txBody>
+          <a:bodyPr wrap="square" lIns="137160" rIns="137160" tIns="91440" bIns="91440">
+            <a:spAutoFit/>
+          </a:bodyPr>
+          <a:lstStyle/>
+          <a:p>
+            <a:r>
+              <a:rPr sz="1400">
+                <a:solidFill>
+                  <a:srgbClr val="333333"/>
+                </a:solidFill>
+                <a:latin typeface="Consolas"/>
+              </a:rPr>
+              <a:t>int main() {</a:t>
+            </a:r>
+          </a:p>
+          <a:p>
+            <a:r>
+              <a:rPr sz="1400">
+                <a:solidFill>
+                  <a:srgbClr val="333333"/>
+                </a:solidFill>
+                <a:latin typeface="Consolas"/>
+              </a:rPr>
+              <a:t>    int year;</a:t>
+            </a:r>
+          </a:p>
+          <a:p>
+            <a:r>
+              <a:rPr sz="1400">
+                <a:solidFill>
+                  <a:srgbClr val="333333"/>
+                </a:solidFill>
+                <a:latin typeface="Consolas"/>
+              </a:rPr>
+              <a:t>    cin&gt;&gt;year;</a:t>
+            </a:r>
+          </a:p>
+          <a:p>
+            <a:r>
+              <a:rPr sz="1400">
+                <a:solidFill>
+                  <a:srgbClr val="333333"/>
+                </a:solidFill>
+                <a:latin typeface="Consolas"/>
+              </a:rPr>
+              <a:t>    if((year%4==0 &amp;&amp; year%100!=0) || (year%400==0))</a:t>
+            </a:r>
+          </a:p>
+          <a:p>
+            <a:r>
+              <a:rPr sz="1400">
+                <a:solidFill>
+                  <a:srgbClr val="333333"/>
+                </a:solidFill>
+                <a:latin typeface="Consolas"/>
+              </a:rPr>
+              <a:t>        cout&lt;&lt;1&lt;&lt;endl;</a:t>
+            </a:r>
+          </a:p>
+          <a:p>
+            <a:r>
+              <a:rPr sz="1400">
+                <a:solidFill>
+                  <a:srgbClr val="333333"/>
+                </a:solidFill>
+                <a:latin typeface="Consolas"/>
+              </a:rPr>
+              <a:t>    else</a:t>
+            </a:r>
+          </a:p>
+          <a:p>
+            <a:r>
+              <a:rPr sz="1400">
+                <a:solidFill>
+                  <a:srgbClr val="333333"/>
+                </a:solidFill>
+                <a:latin typeface="Consolas"/>
+              </a:rPr>
+              <a:t>        cout&lt;&lt;0&lt;&lt;endl;</a:t>
+            </a:r>
+          </a:p>
+          <a:p>
+            <a:r>
+              <a:rPr sz="1400">
+                <a:solidFill>
+                  <a:srgbClr val="333333"/>
+                </a:solidFill>
+                <a:latin typeface="Consolas"/>
+              </a:rPr>
+              <a:t>    return 0;</a:t>
+            </a:r>
+          </a:p>
+          <a:p>
+            <a:r>
+              <a:rPr sz="1400">
+                <a:solidFill>
+                  <a:srgbClr val="333333"/>
+                </a:solidFill>
+                <a:latin typeface="Consolas"/>
+              </a:rPr>
+              <a:t>}</a:t>
+            </a:r>
+          </a:p>
+        </p:txBody>
+      </p:sp>
+      <p:sp>
+        <p:nvSpPr>
+          <p:cNvPr id="6" name="TextBox 5"/>
+          <p:cNvSpPr txBox="1"/>
+          <p:nvPr/>
+        </p:nvSpPr>
+        <p:spPr>
+          <a:xfrm>
+            <a:off x="548640" y="6446520"/>
+            <a:ext cx="11064240" cy="320040"/>
+          </a:xfrm>
+          <a:prstGeom prst="rect">
+            <a:avLst/>
+          </a:prstGeom>
+          <a:noFill/>
+        </p:spPr>
+        <p:txBody>
           <a:bodyPr wrap="none">
             <a:spAutoFit/>
           </a:bodyPr>
@@ -5191,7 +6892,7 @@
                   <a:srgbClr val="999999"/>
                 </a:solidFill>
               </a:rPr>
-              <a:t>演算法之美/</a:t>
+              <a:t>c++ 基礎知識/練習4.cpp</a:t>
             </a:r>
           </a:p>
         </p:txBody>
@@ -5237,12 +6938,12 @@
           <a:lstStyle/>
           <a:p>
             <a:r>
-              <a:rPr sz="3600" b="1">
+              <a:rPr sz="3200" b="1">
                 <a:solidFill>
                   <a:srgbClr val="1F3B57"/>
                 </a:solidFill>
               </a:rPr>
-              <a:t>重點回顧</a:t>
+              <a:t>c++ 基礎知識 — 練習5</a:t>
             </a:r>
           </a:p>
         </p:txBody>
@@ -5299,8 +7000,8 @@
         </p:nvSpPr>
         <p:spPr>
           <a:xfrm>
-            <a:off x="548640" y="1463040"/>
-            <a:ext cx="11064240" cy="4846320"/>
+            <a:off x="548640" y="1371600"/>
+            <a:ext cx="11064240" cy="640080"/>
           </a:xfrm>
           <a:prstGeom prst="rect">
             <a:avLst/>
@@ -5313,63 +7014,13 @@
           </a:bodyPr>
           <a:lstStyle/>
           <a:p>
-            <a:pPr>
-              <a:spcAft>
-                <a:spcPts val="1000"/>
-              </a:spcAft>
-            </a:pPr>
-            <a:r>
-              <a:rPr sz="2200">
+            <a:r>
+              <a:rPr sz="1800">
                 <a:solidFill>
                   <a:srgbClr val="2B2B2B"/>
                 </a:solidFill>
               </a:rPr>
-              <a:t>固定大小陣列必須「猜」容量，猜錯就會越界，是常見的 C++ 錯誤來源</a:t>
-            </a:r>
-          </a:p>
-          <a:p>
-            <a:pPr>
-              <a:spcAft>
-                <a:spcPts val="1000"/>
-              </a:spcAft>
-            </a:pPr>
-            <a:r>
-              <a:rPr sz="2200">
-                <a:solidFill>
-                  <a:srgbClr val="2B2B2B"/>
-                </a:solidFill>
-              </a:rPr>
-              <a:t>std::vector 提供動態成長的陣列，是更安全、更慣用的 C++ 寫法</a:t>
-            </a:r>
-          </a:p>
-          <a:p>
-            <a:pPr>
-              <a:spcAft>
-                <a:spcPts val="1000"/>
-              </a:spcAft>
-            </a:pPr>
-            <a:r>
-              <a:rPr sz="2200">
-                <a:solidFill>
-                  <a:srgbClr val="2B2B2B"/>
-                </a:solidFill>
-              </a:rPr>
-              <a:t>每個練習都可用同樣方式編譯測試：g++ 檔名.cpp -o 執行檔 &amp;&amp; ./執行檔</a:t>
-            </a:r>
-          </a:p>
-          <a:p>
-            <a:pPr>
-              <a:spcAft>
-                <a:spcPts val="1000"/>
-              </a:spcAft>
-            </a:pPr>
-            <a:r>
-              <a:rPr sz="2200">
-                <a:solidFill>
-                  <a:srgbClr val="2B2B2B"/>
-                </a:solidFill>
-              </a:rPr>
-              <a:t>README.md 是整個倉庫的題目索引，新增或修改題目時記得同步更新</a:t>
+              <a:t>輸入體重(kg)和身高(m)，根據 BMI 指數判斷體型</a:t>
             </a:r>
           </a:p>
         </p:txBody>
@@ -5377,6 +7028,179 @@
       <p:sp>
         <p:nvSpPr>
           <p:cNvPr id="5" name="TextBox 4"/>
+          <p:cNvSpPr txBox="1"/>
+          <p:nvPr/>
+        </p:nvSpPr>
+        <p:spPr>
+          <a:xfrm>
+            <a:off x="548640" y="2103120"/>
+            <a:ext cx="11064240" cy="4114800"/>
+          </a:xfrm>
+          <a:prstGeom prst="rect">
+            <a:avLst/>
+          </a:prstGeom>
+          <a:solidFill>
+            <a:srgbClr val="F4F4F4"/>
+          </a:solidFill>
+          <a:ln w="9525">
+            <a:solidFill>
+              <a:srgbClr val="D0D0D0"/>
+            </a:solidFill>
+          </a:ln>
+        </p:spPr>
+        <p:txBody>
+          <a:bodyPr wrap="square" lIns="137160" rIns="137160" tIns="91440" bIns="91440">
+            <a:spAutoFit/>
+          </a:bodyPr>
+          <a:lstStyle/>
+          <a:p>
+            <a:r>
+              <a:rPr sz="1400">
+                <a:solidFill>
+                  <a:srgbClr val="333333"/>
+                </a:solidFill>
+                <a:latin typeface="Consolas"/>
+              </a:rPr>
+              <a:t>int main() {</a:t>
+            </a:r>
+          </a:p>
+          <a:p>
+            <a:r>
+              <a:rPr sz="1400">
+                <a:solidFill>
+                  <a:srgbClr val="333333"/>
+                </a:solidFill>
+                <a:latin typeface="Consolas"/>
+              </a:rPr>
+              <a:t>    float weight,height,result;</a:t>
+            </a:r>
+          </a:p>
+          <a:p>
+            <a:r>
+              <a:rPr sz="1400">
+                <a:solidFill>
+                  <a:srgbClr val="333333"/>
+                </a:solidFill>
+                <a:latin typeface="Consolas"/>
+              </a:rPr>
+              <a:t>    cout&lt;&lt;"輸入體重(kg) 身高(m)"&lt;&lt;endl;</a:t>
+            </a:r>
+          </a:p>
+          <a:p>
+            <a:r>
+              <a:rPr sz="1400">
+                <a:solidFill>
+                  <a:srgbClr val="333333"/>
+                </a:solidFill>
+                <a:latin typeface="Consolas"/>
+              </a:rPr>
+              <a:t>    cin &gt;&gt; weight &gt;&gt; height;</a:t>
+            </a:r>
+          </a:p>
+          <a:p>
+            <a:r>
+              <a:rPr sz="1400">
+                <a:solidFill>
+                  <a:srgbClr val="333333"/>
+                </a:solidFill>
+                <a:latin typeface="Consolas"/>
+              </a:rPr>
+              <a:t>    result =weight/(height*height);</a:t>
+            </a:r>
+          </a:p>
+          <a:p>
+            <a:r>
+              <a:rPr sz="1400">
+                <a:solidFill>
+                  <a:srgbClr val="333333"/>
+                </a:solidFill>
+                <a:latin typeface="Consolas"/>
+              </a:rPr>
+              <a:t>    if (result&lt;18.5)</a:t>
+            </a:r>
+          </a:p>
+          <a:p>
+            <a:r>
+              <a:rPr sz="1400">
+                <a:solidFill>
+                  <a:srgbClr val="333333"/>
+                </a:solidFill>
+                <a:latin typeface="Consolas"/>
+              </a:rPr>
+              <a:t>        cout&lt;&lt; "BMI:"&lt;&lt;result&lt;&lt;"  Underweight"&lt;&lt;endl;</a:t>
+            </a:r>
+          </a:p>
+          <a:p>
+            <a:r>
+              <a:rPr sz="1400">
+                <a:solidFill>
+                  <a:srgbClr val="333333"/>
+                </a:solidFill>
+                <a:latin typeface="Consolas"/>
+              </a:rPr>
+              <a:t>    else if (result&gt;=18.5 &amp;&amp; result&lt;24)</a:t>
+            </a:r>
+          </a:p>
+          <a:p>
+            <a:r>
+              <a:rPr sz="1400">
+                <a:solidFill>
+                  <a:srgbClr val="333333"/>
+                </a:solidFill>
+                <a:latin typeface="Consolas"/>
+              </a:rPr>
+              <a:t>        cout&lt;&lt; "BMI:"&lt;&lt;result&lt;&lt;"  Normal"&lt;&lt;endl;</a:t>
+            </a:r>
+          </a:p>
+          <a:p>
+            <a:r>
+              <a:rPr sz="1400">
+                <a:solidFill>
+                  <a:srgbClr val="333333"/>
+                </a:solidFill>
+                <a:latin typeface="Consolas"/>
+              </a:rPr>
+              <a:t>    else</a:t>
+            </a:r>
+          </a:p>
+          <a:p>
+            <a:r>
+              <a:rPr sz="1400">
+                <a:solidFill>
+                  <a:srgbClr val="333333"/>
+                </a:solidFill>
+                <a:latin typeface="Consolas"/>
+              </a:rPr>
+              <a:t>        cout&lt;&lt; "BMI:"&lt;&lt;result&lt;&lt;"  Overweight"&lt;&lt;endl;</a:t>
+            </a:r>
+          </a:p>
+          <a:p>
+            <a:r>
+              <a:rPr sz="1400">
+                <a:solidFill>
+                  <a:srgbClr val="333333"/>
+                </a:solidFill>
+                <a:latin typeface="Consolas"/>
+              </a:rPr>
+              <a:t>    return 0;</a:t>
+            </a:r>
+          </a:p>
+          <a:p>
+            <a:r>
+              <a:rPr sz="1400">
+                <a:solidFill>
+                  <a:srgbClr val="333333"/>
+                </a:solidFill>
+                <a:latin typeface="Consolas"/>
+              </a:rPr>
+              <a:t>}</a:t>
+            </a:r>
+          </a:p>
+        </p:txBody>
+      </p:sp>
+      <p:sp>
+        <p:nvSpPr>
+          <p:cNvPr id="6" name="TextBox 5"/>
           <p:cNvSpPr txBox="1"/>
           <p:nvPr/>
         </p:nvSpPr>
@@ -5402,7 +7226,352 @@
                   <a:srgbClr val="999999"/>
                 </a:solidFill>
               </a:rPr>
-              <a:t>cplusplus_practice</a:t>
+              <a:t>c++ 基礎知識/練習5.cpp</a:t>
+            </a:r>
+          </a:p>
+        </p:txBody>
+      </p:sp>
+    </p:spTree>
+  </p:cSld>
+  <p:clrMapOvr>
+    <a:masterClrMapping/>
+  </p:clrMapOvr>
+</p:sld>
+</file>
+
+<file path=ppt/slides/slide9.xml><?xml version="1.0" encoding="utf-8"?>
+<p:sld xmlns:a="http://schemas.openxmlformats.org/drawingml/2006/main" xmlns:p="http://schemas.openxmlformats.org/presentationml/2006/main" xmlns:r="http://schemas.openxmlformats.org/officeDocument/2006/relationships">
+  <p:cSld>
+    <p:spTree>
+      <p:nvGrpSpPr>
+        <p:cNvPr id="1" name=""/>
+        <p:cNvGrpSpPr/>
+        <p:nvPr/>
+      </p:nvGrpSpPr>
+      <p:grpSpPr/>
+      <p:sp>
+        <p:nvSpPr>
+          <p:cNvPr id="2" name="TextBox 1"/>
+          <p:cNvSpPr txBox="1"/>
+          <p:nvPr/>
+        </p:nvSpPr>
+        <p:spPr>
+          <a:xfrm>
+            <a:off x="548640" y="320040"/>
+            <a:ext cx="11064240" cy="914400"/>
+          </a:xfrm>
+          <a:prstGeom prst="rect">
+            <a:avLst/>
+          </a:prstGeom>
+          <a:noFill/>
+        </p:spPr>
+        <p:txBody>
+          <a:bodyPr wrap="square">
+            <a:spAutoFit/>
+          </a:bodyPr>
+          <a:lstStyle/>
+          <a:p>
+            <a:r>
+              <a:rPr sz="3200" b="1">
+                <a:solidFill>
+                  <a:srgbClr val="1F3B57"/>
+                </a:solidFill>
+              </a:rPr>
+              <a:t>c++ 基礎知識 — 練習6</a:t>
+            </a:r>
+          </a:p>
+        </p:txBody>
+      </p:sp>
+      <p:sp>
+        <p:nvSpPr>
+          <p:cNvPr id="3" name="Rectangle 2"/>
+          <p:cNvSpPr/>
+          <p:nvPr/>
+        </p:nvSpPr>
+        <p:spPr>
+          <a:xfrm>
+            <a:off x="0" y="1143000"/>
+            <a:ext cx="12191695" cy="54864"/>
+          </a:xfrm>
+          <a:prstGeom prst="rect">
+            <a:avLst/>
+          </a:prstGeom>
+          <a:solidFill>
+            <a:srgbClr val="2E86AB"/>
+          </a:solidFill>
+          <a:ln>
+            <a:noFill/>
+          </a:ln>
+          <a:effectLst/>
+        </p:spPr>
+        <p:style>
+          <a:lnRef idx="1">
+            <a:schemeClr val="accent1"/>
+          </a:lnRef>
+          <a:fillRef idx="3">
+            <a:schemeClr val="accent1"/>
+          </a:fillRef>
+          <a:effectRef idx="2">
+            <a:schemeClr val="accent1"/>
+          </a:effectRef>
+          <a:fontRef idx="minor">
+            <a:schemeClr val="lt1"/>
+          </a:fontRef>
+        </p:style>
+        <p:txBody>
+          <a:bodyPr rtlCol="0" anchor="ctr"/>
+          <a:lstStyle/>
+          <a:p>
+            <a:pPr algn="ctr"/>
+          </a:p>
+        </p:txBody>
+      </p:sp>
+      <p:sp>
+        <p:nvSpPr>
+          <p:cNvPr id="4" name="TextBox 3"/>
+          <p:cNvSpPr txBox="1"/>
+          <p:nvPr/>
+        </p:nvSpPr>
+        <p:spPr>
+          <a:xfrm>
+            <a:off x="548640" y="1371600"/>
+            <a:ext cx="11064240" cy="640080"/>
+          </a:xfrm>
+          <a:prstGeom prst="rect">
+            <a:avLst/>
+          </a:prstGeom>
+          <a:noFill/>
+        </p:spPr>
+        <p:txBody>
+          <a:bodyPr wrap="square">
+            <a:spAutoFit/>
+          </a:bodyPr>
+          <a:lstStyle/>
+          <a:p>
+            <a:r>
+              <a:rPr sz="1800">
+                <a:solidFill>
+                  <a:srgbClr val="2B2B2B"/>
+                </a:solidFill>
+              </a:rPr>
+              <a:t>給定一個整數 x，判斷它能否被 3、5、7 整除，並輸出相關資訊</a:t>
+            </a:r>
+          </a:p>
+        </p:txBody>
+      </p:sp>
+      <p:sp>
+        <p:nvSpPr>
+          <p:cNvPr id="5" name="TextBox 4"/>
+          <p:cNvSpPr txBox="1"/>
+          <p:nvPr/>
+        </p:nvSpPr>
+        <p:spPr>
+          <a:xfrm>
+            <a:off x="548640" y="2103120"/>
+            <a:ext cx="11064240" cy="4114800"/>
+          </a:xfrm>
+          <a:prstGeom prst="rect">
+            <a:avLst/>
+          </a:prstGeom>
+          <a:solidFill>
+            <a:srgbClr val="F4F4F4"/>
+          </a:solidFill>
+          <a:ln w="9525">
+            <a:solidFill>
+              <a:srgbClr val="D0D0D0"/>
+            </a:solidFill>
+          </a:ln>
+        </p:spPr>
+        <p:txBody>
+          <a:bodyPr wrap="square" lIns="137160" rIns="137160" tIns="91440" bIns="91440">
+            <a:spAutoFit/>
+          </a:bodyPr>
+          <a:lstStyle/>
+          <a:p>
+            <a:r>
+              <a:rPr sz="1400">
+                <a:solidFill>
+                  <a:srgbClr val="333333"/>
+                </a:solidFill>
+                <a:latin typeface="Consolas"/>
+              </a:rPr>
+              <a:t>int main() {</a:t>
+            </a:r>
+          </a:p>
+          <a:p>
+            <a:r>
+              <a:rPr sz="1400">
+                <a:solidFill>
+                  <a:srgbClr val="333333"/>
+                </a:solidFill>
+                <a:latin typeface="Consolas"/>
+              </a:rPr>
+              <a:t>    int x;</a:t>
+            </a:r>
+          </a:p>
+          <a:p>
+            <a:r>
+              <a:rPr sz="1400">
+                <a:solidFill>
+                  <a:srgbClr val="333333"/>
+                </a:solidFill>
+                <a:latin typeface="Consolas"/>
+              </a:rPr>
+              <a:t>    cin&gt;&gt;x;</a:t>
+            </a:r>
+          </a:p>
+          <a:p>
+            <a:r>
+              <a:rPr sz="1400">
+                <a:solidFill>
+                  <a:srgbClr val="333333"/>
+                </a:solidFill>
+                <a:latin typeface="Consolas"/>
+              </a:rPr>
+              <a:t>    if (x%3==0)</a:t>
+            </a:r>
+          </a:p>
+          <a:p>
+            <a:r>
+              <a:rPr sz="1400">
+                <a:solidFill>
+                  <a:srgbClr val="333333"/>
+                </a:solidFill>
+                <a:latin typeface="Consolas"/>
+              </a:rPr>
+              <a:t>        cout&lt;&lt;"3 ";</a:t>
+            </a:r>
+          </a:p>
+          <a:p>
+            <a:r>
+              <a:rPr sz="1400">
+                <a:solidFill>
+                  <a:srgbClr val="333333"/>
+                </a:solidFill>
+                <a:latin typeface="Consolas"/>
+              </a:rPr>
+              <a:t>    if (x%5==0)</a:t>
+            </a:r>
+          </a:p>
+          <a:p>
+            <a:r>
+              <a:rPr sz="1400">
+                <a:solidFill>
+                  <a:srgbClr val="333333"/>
+                </a:solidFill>
+                <a:latin typeface="Consolas"/>
+              </a:rPr>
+              <a:t>        cout&lt;&lt;"5 ";</a:t>
+            </a:r>
+          </a:p>
+          <a:p>
+            <a:r>
+              <a:rPr sz="1400">
+                <a:solidFill>
+                  <a:srgbClr val="333333"/>
+                </a:solidFill>
+                <a:latin typeface="Consolas"/>
+              </a:rPr>
+              <a:t>    if (x%7==0)</a:t>
+            </a:r>
+          </a:p>
+          <a:p>
+            <a:r>
+              <a:rPr sz="1400">
+                <a:solidFill>
+                  <a:srgbClr val="333333"/>
+                </a:solidFill>
+                <a:latin typeface="Consolas"/>
+              </a:rPr>
+              <a:t>        cout&lt;&lt;"7";</a:t>
+            </a:r>
+          </a:p>
+          <a:p>
+            <a:r>
+              <a:rPr sz="1400">
+                <a:solidFill>
+                  <a:srgbClr val="333333"/>
+                </a:solidFill>
+                <a:latin typeface="Consolas"/>
+              </a:rPr>
+              <a:t>    if (x%3 &amp;&amp; x%5 &amp;&amp; x%7)</a:t>
+            </a:r>
+          </a:p>
+          <a:p>
+            <a:r>
+              <a:rPr sz="1400">
+                <a:solidFill>
+                  <a:srgbClr val="333333"/>
+                </a:solidFill>
+                <a:latin typeface="Consolas"/>
+              </a:rPr>
+              <a:t>        cout&lt;&lt;"n";</a:t>
+            </a:r>
+          </a:p>
+          <a:p>
+            <a:r>
+              <a:rPr sz="1400">
+                <a:solidFill>
+                  <a:srgbClr val="333333"/>
+                </a:solidFill>
+                <a:latin typeface="Consolas"/>
+              </a:rPr>
+              <a:t>    cout&lt;&lt;"\n";</a:t>
+            </a:r>
+          </a:p>
+          <a:p>
+            <a:r>
+              <a:rPr sz="1400">
+                <a:solidFill>
+                  <a:srgbClr val="333333"/>
+                </a:solidFill>
+                <a:latin typeface="Consolas"/>
+              </a:rPr>
+              <a:t>    return 0;</a:t>
+            </a:r>
+          </a:p>
+          <a:p>
+            <a:r>
+              <a:rPr sz="1400">
+                <a:solidFill>
+                  <a:srgbClr val="333333"/>
+                </a:solidFill>
+                <a:latin typeface="Consolas"/>
+              </a:rPr>
+              <a:t>}</a:t>
+            </a:r>
+          </a:p>
+        </p:txBody>
+      </p:sp>
+      <p:sp>
+        <p:nvSpPr>
+          <p:cNvPr id="6" name="TextBox 5"/>
+          <p:cNvSpPr txBox="1"/>
+          <p:nvPr/>
+        </p:nvSpPr>
+        <p:spPr>
+          <a:xfrm>
+            <a:off x="548640" y="6446520"/>
+            <a:ext cx="11064240" cy="320040"/>
+          </a:xfrm>
+          <a:prstGeom prst="rect">
+            <a:avLst/>
+          </a:prstGeom>
+          <a:noFill/>
+        </p:spPr>
+        <p:txBody>
+          <a:bodyPr wrap="none">
+            <a:spAutoFit/>
+          </a:bodyPr>
+          <a:lstStyle/>
+          <a:p>
+            <a:r>
+              <a:rPr sz="1200">
+                <a:solidFill>
+                  <a:srgbClr val="999999"/>
+                </a:solidFill>
+              </a:rPr>
+              <a:t>c++ 基礎知識/練習6.cpp</a:t>
             </a:r>
           </a:p>
         </p:txBody>

</xml_diff>

<commit_message>
Add 演算法之美 overview table slide to the PPT
補上跟 c++ 基礎知識 一樣的題目列表頁，列出 演算法之美 資料夾內的檔案與題目說明。

Co-Authored-By: Claude Sonnet 5 <noreply@anthropic.com>
</commit_message>
<xml_diff>
--- a/practice_intro.pptx
+++ b/practice_intro.pptx
@@ -20,6 +20,7 @@
     <p:sldId id="268" r:id="rId19"/>
     <p:sldId id="269" r:id="rId20"/>
     <p:sldId id="270" r:id="rId21"/>
+    <p:sldId id="271" r:id="rId22"/>
   </p:sldIdLst>
   <p:sldSz cx="12191695" cy="6858000" type="screen4x3"/>
   <p:notesSz cx="6858000" cy="9144000"/>
@@ -3559,7 +3560,7 @@
                   <a:srgbClr val="1F3B57"/>
                 </a:solidFill>
               </a:rPr>
-              <a:t>演算法之美 — 練習1</a:t>
+              <a:t>演算法之美 — 題目列表</a:t>
             </a:r>
           </a:p>
         </p:txBody>
@@ -3608,16 +3609,170 @@
           </a:p>
         </p:txBody>
       </p:sp>
-      <p:sp>
-        <p:nvSpPr>
-          <p:cNvPr id="4" name="TextBox 3"/>
+      <p:graphicFrame>
+        <p:nvGraphicFramePr>
+          <p:cNvPr id="4" name="Table 3"/>
+          <p:cNvGraphicFramePr>
+            <a:graphicFrameLocks noGrp="1"/>
+          </p:cNvGraphicFramePr>
+          <p:nvPr/>
+        </p:nvGraphicFramePr>
+        <p:xfrm>
+          <a:off x="548640" y="1463040"/>
+          <a:ext cx="11064240" cy="2194560"/>
+        </p:xfrm>
+        <a:graphic>
+          <a:graphicData uri="http://schemas.openxmlformats.org/drawingml/2006/table">
+            <a:tbl>
+              <a:tblPr firstRow="1" bandRow="1">
+                <a:tableStyleId>{5C22544A-7EE6-4342-B048-85BDC9FD1C3A}</a:tableStyleId>
+              </a:tblPr>
+              <a:tblGrid>
+                <a:gridCol w="2743200"/>
+                <a:gridCol w="8321040"/>
+              </a:tblGrid>
+              <a:tr h="731520">
+                <a:tc>
+                  <a:txBody>
+                    <a:bodyPr/>
+                    <a:lstStyle/>
+                    <a:p>
+                      <a:pPr>
+                        <a:defRPr b="1" sz="1600">
+                          <a:solidFill>
+                            <a:srgbClr val="FFFFFF"/>
+                          </a:solidFill>
+                        </a:defRPr>
+                      </a:pPr>
+                      <a:r>
+                        <a:t>檔案</a:t>
+                      </a:r>
+                    </a:p>
+                  </a:txBody>
+                  <a:tcPr>
+                    <a:solidFill>
+                      <a:srgbClr val="2E86AB"/>
+                    </a:solidFill>
+                  </a:tcPr>
+                </a:tc>
+                <a:tc>
+                  <a:txBody>
+                    <a:bodyPr/>
+                    <a:lstStyle/>
+                    <a:p>
+                      <a:pPr>
+                        <a:defRPr b="1" sz="1600">
+                          <a:solidFill>
+                            <a:srgbClr val="FFFFFF"/>
+                          </a:solidFill>
+                        </a:defRPr>
+                      </a:pPr>
+                      <a:r>
+                        <a:t>題目</a:t>
+                      </a:r>
+                    </a:p>
+                  </a:txBody>
+                  <a:tcPr>
+                    <a:solidFill>
+                      <a:srgbClr val="2E86AB"/>
+                    </a:solidFill>
+                  </a:tcPr>
+                </a:tc>
+              </a:tr>
+              <a:tr h="731520">
+                <a:tc>
+                  <a:txBody>
+                    <a:bodyPr/>
+                    <a:lstStyle/>
+                    <a:p>
+                      <a:pPr>
+                        <a:defRPr sz="1400">
+                          <a:solidFill>
+                            <a:srgbClr val="2B2B2B"/>
+                          </a:solidFill>
+                        </a:defRPr>
+                      </a:pPr>
+                      <a:r>
+                        <a:t>練習1.cpp</a:t>
+                      </a:r>
+                    </a:p>
+                  </a:txBody>
+                  <a:tcPr/>
+                </a:tc>
+                <a:tc>
+                  <a:txBody>
+                    <a:bodyPr/>
+                    <a:lstStyle/>
+                    <a:p>
+                      <a:pPr>
+                        <a:defRPr sz="1400">
+                          <a:solidFill>
+                            <a:srgbClr val="2B2B2B"/>
+                          </a:solidFill>
+                        </a:defRPr>
+                      </a:pPr>
+                      <a:r>
+                        <a:t>輸入 x, y，輸出 [x, y] 區間閏年的數量，並在下一行輸出所有閏年的年份數字</a:t>
+                      </a:r>
+                    </a:p>
+                  </a:txBody>
+                  <a:tcPr/>
+                </a:tc>
+              </a:tr>
+              <a:tr h="731520">
+                <a:tc>
+                  <a:txBody>
+                    <a:bodyPr/>
+                    <a:lstStyle/>
+                    <a:p>
+                      <a:pPr>
+                        <a:defRPr sz="1400">
+                          <a:solidFill>
+                            <a:srgbClr val="2B2B2B"/>
+                          </a:solidFill>
+                        </a:defRPr>
+                      </a:pPr>
+                      <a:r>
+                        <a:t>練習1-adviced.cpp</a:t>
+                      </a:r>
+                    </a:p>
+                  </a:txBody>
+                  <a:tcPr/>
+                </a:tc>
+                <a:tc>
+                  <a:txBody>
+                    <a:bodyPr/>
+                    <a:lstStyle/>
+                    <a:p>
+                      <a:pPr>
+                        <a:defRPr sz="1400">
+                          <a:solidFill>
+                            <a:srgbClr val="2B2B2B"/>
+                          </a:solidFill>
+                        </a:defRPr>
+                      </a:pPr>
+                      <a:r>
+                        <a:t>練習1 的改進版：改用 std::vector 取代固定大小陣列</a:t>
+                      </a:r>
+                    </a:p>
+                  </a:txBody>
+                  <a:tcPr/>
+                </a:tc>
+              </a:tr>
+            </a:tbl>
+          </a:graphicData>
+        </a:graphic>
+      </p:graphicFrame>
+      <p:sp>
+        <p:nvSpPr>
+          <p:cNvPr id="5" name="TextBox 4"/>
           <p:cNvSpPr txBox="1"/>
           <p:nvPr/>
         </p:nvSpPr>
         <p:spPr>
           <a:xfrm>
-            <a:off x="548640" y="1463040"/>
-            <a:ext cx="11064240" cy="4846320"/>
+            <a:off x="548640" y="3931920"/>
+            <a:ext cx="11064240" cy="1371600"/>
           </a:xfrm>
           <a:prstGeom prst="rect">
             <a:avLst/>
@@ -3636,34 +3791,19 @@
               </a:spcAft>
             </a:pPr>
             <a:r>
-              <a:rPr sz="2200">
+              <a:rPr sz="1800">
                 <a:solidFill>
                   <a:srgbClr val="2B2B2B"/>
                 </a:solidFill>
               </a:rPr>
-              <a:t>題目：輸入 x, y，輸出 [x, y] 區間閏年的數量，並在下一行輸出所有閏年的年份數字</a:t>
-            </a:r>
-          </a:p>
-          <a:p>
-            <a:pPr>
-              <a:spcAft>
-                <a:spcPts val="1000"/>
-              </a:spcAft>
-            </a:pPr>
-            <a:r>
-              <a:rPr sz="2200">
-                <a:solidFill>
-                  <a:srgbClr val="2B2B2B"/>
-                </a:solidFill>
-              </a:rPr>
-              <a:t>重點：不只是解題，更展示了如何發現並改進程式碼中的潛在風險</a:t>
-            </a:r>
-          </a:p>
-        </p:txBody>
-      </p:sp>
-      <p:sp>
-        <p:nvSpPr>
-          <p:cNvPr id="5" name="TextBox 4"/>
+              <a:t>這個資料夾除了解題，也示範了如何發現並改進程式碼中的潛在風險（見後續頁面）</a:t>
+            </a:r>
+          </a:p>
+        </p:txBody>
+      </p:sp>
+      <p:sp>
+        <p:nvSpPr>
+          <p:cNvPr id="6" name="TextBox 5"/>
           <p:cNvSpPr txBox="1"/>
           <p:nvPr/>
         </p:nvSpPr>
@@ -3689,7 +3829,7 @@
                   <a:srgbClr val="999999"/>
                 </a:solidFill>
               </a:rPr>
-              <a:t>演算法之美/練習1.cpp</a:t>
+              <a:t>演算法之美/</a:t>
             </a:r>
           </a:p>
         </p:txBody>
@@ -3735,12 +3875,12 @@
           <a:lstStyle/>
           <a:p>
             <a:r>
-              <a:rPr sz="3200" b="1">
+              <a:rPr sz="3600" b="1">
                 <a:solidFill>
                   <a:srgbClr val="1F3B57"/>
                 </a:solidFill>
               </a:rPr>
-              <a:t>原始版本：固定大小陣列的風險</a:t>
+              <a:t>演算法之美 — 練習1</a:t>
             </a:r>
           </a:p>
         </p:txBody>
@@ -3797,115 +3937,8 @@
         </p:nvSpPr>
         <p:spPr>
           <a:xfrm>
-            <a:off x="548640" y="1554480"/>
-            <a:ext cx="6400800" cy="2743200"/>
-          </a:xfrm>
-          <a:prstGeom prst="rect">
-            <a:avLst/>
-          </a:prstGeom>
-          <a:solidFill>
-            <a:srgbClr val="F4F4F4"/>
-          </a:solidFill>
-          <a:ln w="9525">
-            <a:solidFill>
-              <a:srgbClr val="D0D0D0"/>
-            </a:solidFill>
-          </a:ln>
-        </p:spPr>
-        <p:txBody>
-          <a:bodyPr wrap="square" lIns="137160" rIns="137160" tIns="91440" bIns="91440">
-            <a:spAutoFit/>
-          </a:bodyPr>
-          <a:lstStyle/>
-          <a:p>
-            <a:r>
-              <a:rPr sz="1600">
-                <a:solidFill>
-                  <a:srgbClr val="333333"/>
-                </a:solidFill>
-                <a:latin typeface="Consolas"/>
-              </a:rPr>
-              <a:t>int ans[1000];</a:t>
-            </a:r>
-          </a:p>
-          <a:p>
-            <a:r>
-              <a:rPr sz="1600">
-                <a:solidFill>
-                  <a:srgbClr val="333333"/>
-                </a:solidFill>
-                <a:latin typeface="Consolas"/>
-              </a:rPr>
-              <a:t/>
-            </a:r>
-          </a:p>
-          <a:p>
-            <a:r>
-              <a:rPr sz="1600">
-                <a:solidFill>
-                  <a:srgbClr val="333333"/>
-                </a:solidFill>
-                <a:latin typeface="Consolas"/>
-              </a:rPr>
-              <a:t>for (int i = x; i &lt;= y; i++) {</a:t>
-            </a:r>
-          </a:p>
-          <a:p>
-            <a:r>
-              <a:rPr sz="1600">
-                <a:solidFill>
-                  <a:srgbClr val="333333"/>
-                </a:solidFill>
-                <a:latin typeface="Consolas"/>
-              </a:rPr>
-              <a:t>    if (judge(i)) {</a:t>
-            </a:r>
-          </a:p>
-          <a:p>
-            <a:r>
-              <a:rPr sz="1600">
-                <a:solidFill>
-                  <a:srgbClr val="333333"/>
-                </a:solidFill>
-                <a:latin typeface="Consolas"/>
-              </a:rPr>
-              <a:t>        ans[cnt++] = i;   // cnt 超過 1000 就會越界！</a:t>
-            </a:r>
-          </a:p>
-          <a:p>
-            <a:r>
-              <a:rPr sz="1600">
-                <a:solidFill>
-                  <a:srgbClr val="333333"/>
-                </a:solidFill>
-                <a:latin typeface="Consolas"/>
-              </a:rPr>
-              <a:t>    }</a:t>
-            </a:r>
-          </a:p>
-          <a:p>
-            <a:r>
-              <a:rPr sz="1600">
-                <a:solidFill>
-                  <a:srgbClr val="333333"/>
-                </a:solidFill>
-                <a:latin typeface="Consolas"/>
-              </a:rPr>
-              <a:t>}</a:t>
-            </a:r>
-          </a:p>
-        </p:txBody>
-      </p:sp>
-      <p:sp>
-        <p:nvSpPr>
-          <p:cNvPr id="5" name="TextBox 4"/>
-          <p:cNvSpPr txBox="1"/>
-          <p:nvPr/>
-        </p:nvSpPr>
-        <p:spPr>
-          <a:xfrm>
-            <a:off x="7223760" y="1554480"/>
-            <a:ext cx="4480560" cy="4389120"/>
+            <a:off x="548640" y="1463040"/>
+            <a:ext cx="11064240" cy="4846320"/>
           </a:xfrm>
           <a:prstGeom prst="rect">
             <a:avLst/>
@@ -3924,79 +3957,34 @@
               </a:spcAft>
             </a:pPr>
             <a:r>
-              <a:rPr sz="1600">
+              <a:rPr sz="2200">
                 <a:solidFill>
                   <a:srgbClr val="2B2B2B"/>
                 </a:solidFill>
               </a:rPr>
-              <a:t>問題點：</a:t>
-            </a:r>
-          </a:p>
-          <a:p>
-            <a:pPr lvl="1">
+              <a:t>題目：輸入 x, y，輸出 [x, y] 區間閏年的數量，並在下一行輸出所有閏年的年份數字</a:t>
+            </a:r>
+          </a:p>
+          <a:p>
+            <a:pPr>
               <a:spcAft>
                 <a:spcPts val="1000"/>
               </a:spcAft>
             </a:pPr>
             <a:r>
-              <a:rPr sz="1400">
+              <a:rPr sz="2200">
                 <a:solidFill>
                   <a:srgbClr val="2B2B2B"/>
                 </a:solidFill>
               </a:rPr>
-              <a:t>陣列大小 1000 是憑經驗猜測的上限</a:t>
-            </a:r>
-          </a:p>
-          <a:p>
-            <a:pPr lvl="1">
-              <a:spcAft>
-                <a:spcPts val="1000"/>
-              </a:spcAft>
-            </a:pPr>
-            <a:r>
-              <a:rPr sz="1400">
-                <a:solidFill>
-                  <a:srgbClr val="2B2B2B"/>
-                </a:solidFill>
-              </a:rPr>
-              <a:t>若 [x, y] 區間夠大（例如 x=1, y=1000000），閏年數量會遠超過 1000</a:t>
-            </a:r>
-          </a:p>
-          <a:p>
-            <a:pPr lvl="1">
-              <a:spcAft>
-                <a:spcPts val="1000"/>
-              </a:spcAft>
-            </a:pPr>
-            <a:r>
-              <a:rPr sz="1400">
-                <a:solidFill>
-                  <a:srgbClr val="2B2B2B"/>
-                </a:solidFill>
-              </a:rPr>
-              <a:t>超出陣列邊界寫入 = 未定義行為（Undefined Behavior）</a:t>
-            </a:r>
-          </a:p>
-          <a:p>
-            <a:pPr lvl="1">
-              <a:spcAft>
-                <a:spcPts val="1000"/>
-              </a:spcAft>
-            </a:pPr>
-            <a:r>
-              <a:rPr sz="1400">
-                <a:solidFill>
-                  <a:srgbClr val="2B2B2B"/>
-                </a:solidFill>
-              </a:rPr>
-              <a:t>可能導致資料損毀、程式崩潰，且不易察覺、難以除錯</a:t>
-            </a:r>
-          </a:p>
-        </p:txBody>
-      </p:sp>
-      <p:sp>
-        <p:nvSpPr>
-          <p:cNvPr id="6" name="TextBox 5"/>
+              <a:t>重點：不只是解題，更展示了如何發現並改進程式碼中的潛在風險</a:t>
+            </a:r>
+          </a:p>
+        </p:txBody>
+      </p:sp>
+      <p:sp>
+        <p:nvSpPr>
+          <p:cNvPr id="5" name="TextBox 4"/>
           <p:cNvSpPr txBox="1"/>
           <p:nvPr/>
         </p:nvSpPr>
@@ -4073,7 +4061,7 @@
                   <a:srgbClr val="1F3B57"/>
                 </a:solidFill>
               </a:rPr>
-              <a:t>改進版本：std::vector 動態陣列</a:t>
+              <a:t>原始版本：固定大小陣列的風險</a:t>
             </a:r>
           </a:p>
         </p:txBody>
@@ -4131,7 +4119,7 @@
         <p:spPr>
           <a:xfrm>
             <a:off x="548640" y="1554480"/>
-            <a:ext cx="6400800" cy="3291840"/>
+            <a:ext cx="6400800" cy="2743200"/>
           </a:xfrm>
           <a:prstGeom prst="rect">
             <a:avLst/>
@@ -4152,18 +4140,18 @@
           <a:lstStyle/>
           <a:p>
             <a:r>
-              <a:rPr sz="1500">
-                <a:solidFill>
-                  <a:srgbClr val="333333"/>
-                </a:solidFill>
-                <a:latin typeface="Consolas"/>
-              </a:rPr>
-              <a:t>vector&lt;int&gt; ans;   // 不用事先宣告大小</a:t>
-            </a:r>
-          </a:p>
-          <a:p>
-            <a:r>
-              <a:rPr sz="1500">
+              <a:rPr sz="1600">
+                <a:solidFill>
+                  <a:srgbClr val="333333"/>
+                </a:solidFill>
+                <a:latin typeface="Consolas"/>
+              </a:rPr>
+              <a:t>int ans[1000];</a:t>
+            </a:r>
+          </a:p>
+          <a:p>
+            <a:r>
+              <a:rPr sz="1600">
                 <a:solidFill>
                   <a:srgbClr val="333333"/>
                 </a:solidFill>
@@ -4174,7 +4162,7 @@
           </a:p>
           <a:p>
             <a:r>
-              <a:rPr sz="1500">
+              <a:rPr sz="1600">
                 <a:solidFill>
                   <a:srgbClr val="333333"/>
                 </a:solidFill>
@@ -4185,7 +4173,7 @@
           </a:p>
           <a:p>
             <a:r>
-              <a:rPr sz="1500">
+              <a:rPr sz="1600">
                 <a:solidFill>
                   <a:srgbClr val="333333"/>
                 </a:solidFill>
@@ -4196,18 +4184,18 @@
           </a:p>
           <a:p>
             <a:r>
-              <a:rPr sz="1500">
-                <a:solidFill>
-                  <a:srgbClr val="333333"/>
-                </a:solidFill>
-                <a:latin typeface="Consolas"/>
-              </a:rPr>
-              <a:t>        ans.push_back(i);   // 自動成長，不會越界</a:t>
-            </a:r>
-          </a:p>
-          <a:p>
-            <a:r>
-              <a:rPr sz="1500">
+              <a:rPr sz="1600">
+                <a:solidFill>
+                  <a:srgbClr val="333333"/>
+                </a:solidFill>
+                <a:latin typeface="Consolas"/>
+              </a:rPr>
+              <a:t>        ans[cnt++] = i;   // cnt 超過 1000 就會越界！</a:t>
+            </a:r>
+          </a:p>
+          <a:p>
+            <a:r>
+              <a:rPr sz="1600">
                 <a:solidFill>
                   <a:srgbClr val="333333"/>
                 </a:solidFill>
@@ -4218,46 +4206,13 @@
           </a:p>
           <a:p>
             <a:r>
-              <a:rPr sz="1500">
+              <a:rPr sz="1600">
                 <a:solidFill>
                   <a:srgbClr val="333333"/>
                 </a:solidFill>
                 <a:latin typeface="Consolas"/>
               </a:rPr>
               <a:t>}</a:t>
-            </a:r>
-          </a:p>
-          <a:p>
-            <a:r>
-              <a:rPr sz="1500">
-                <a:solidFill>
-                  <a:srgbClr val="333333"/>
-                </a:solidFill>
-                <a:latin typeface="Consolas"/>
-              </a:rPr>
-              <a:t/>
-            </a:r>
-          </a:p>
-          <a:p>
-            <a:r>
-              <a:rPr sz="1500">
-                <a:solidFill>
-                  <a:srgbClr val="333333"/>
-                </a:solidFill>
-                <a:latin typeface="Consolas"/>
-              </a:rPr>
-              <a:t>cout &lt;&lt; ans.size() &lt;&lt; endl;</a:t>
-            </a:r>
-          </a:p>
-          <a:p>
-            <a:r>
-              <a:rPr sz="1500">
-                <a:solidFill>
-                  <a:srgbClr val="333333"/>
-                </a:solidFill>
-                <a:latin typeface="Consolas"/>
-              </a:rPr>
-              <a:t>for (int v : ans) cout &lt;&lt; v &lt;&lt; " ";</a:t>
             </a:r>
           </a:p>
         </p:txBody>
@@ -4295,7 +4250,7 @@
                   <a:srgbClr val="2B2B2B"/>
                 </a:solidFill>
               </a:rPr>
-              <a:t>改進效果：</a:t>
+              <a:t>問題點：</a:t>
             </a:r>
           </a:p>
           <a:p>
@@ -4310,7 +4265,7 @@
                   <a:srgbClr val="2B2B2B"/>
                 </a:solidFill>
               </a:rPr>
-              <a:t>容量隨資料動態成長，無需事先猜測上限</a:t>
+              <a:t>陣列大小 1000 是憑經驗猜測的上限</a:t>
             </a:r>
           </a:p>
           <a:p>
@@ -4325,7 +4280,7 @@
                   <a:srgbClr val="2B2B2B"/>
                 </a:solidFill>
               </a:rPr>
-              <a:t>消除陣列越界的未定義行為風險</a:t>
+              <a:t>若 [x, y] 區間夠大（例如 x=1, y=1000000），閏年數量會遠超過 1000</a:t>
             </a:r>
           </a:p>
           <a:p>
@@ -4340,7 +4295,7 @@
                   <a:srgbClr val="2B2B2B"/>
                 </a:solidFill>
               </a:rPr>
-              <a:t>程式碼更貼近「資料多大就存多大」的直覺</a:t>
+              <a:t>超出陣列邊界寫入 = 未定義行為（Undefined Behavior）</a:t>
             </a:r>
           </a:p>
           <a:p>
@@ -4355,7 +4310,7 @@
                   <a:srgbClr val="2B2B2B"/>
                 </a:solidFill>
               </a:rPr>
-              <a:t>檔案：演算法之美/練習1-adviced.cpp</a:t>
+              <a:t>可能導致資料損毀、程式崩潰，且不易察覺、難以除錯</a:t>
             </a:r>
           </a:p>
         </p:txBody>
@@ -4388,7 +4343,7 @@
                   <a:srgbClr val="999999"/>
                 </a:solidFill>
               </a:rPr>
-              <a:t>演算法之美/練習1-adviced.cpp</a:t>
+              <a:t>演算法之美/練習1.cpp</a:t>
             </a:r>
           </a:p>
         </p:txBody>
@@ -4402,6 +4357,372 @@
 </file>
 
 <file path=ppt/slides/slide14.xml><?xml version="1.0" encoding="utf-8"?>
+<p:sld xmlns:a="http://schemas.openxmlformats.org/drawingml/2006/main" xmlns:p="http://schemas.openxmlformats.org/presentationml/2006/main" xmlns:r="http://schemas.openxmlformats.org/officeDocument/2006/relationships">
+  <p:cSld>
+    <p:spTree>
+      <p:nvGrpSpPr>
+        <p:cNvPr id="1" name=""/>
+        <p:cNvGrpSpPr/>
+        <p:nvPr/>
+      </p:nvGrpSpPr>
+      <p:grpSpPr/>
+      <p:sp>
+        <p:nvSpPr>
+          <p:cNvPr id="2" name="TextBox 1"/>
+          <p:cNvSpPr txBox="1"/>
+          <p:nvPr/>
+        </p:nvSpPr>
+        <p:spPr>
+          <a:xfrm>
+            <a:off x="548640" y="320040"/>
+            <a:ext cx="11064240" cy="914400"/>
+          </a:xfrm>
+          <a:prstGeom prst="rect">
+            <a:avLst/>
+          </a:prstGeom>
+          <a:noFill/>
+        </p:spPr>
+        <p:txBody>
+          <a:bodyPr wrap="square">
+            <a:spAutoFit/>
+          </a:bodyPr>
+          <a:lstStyle/>
+          <a:p>
+            <a:r>
+              <a:rPr sz="3200" b="1">
+                <a:solidFill>
+                  <a:srgbClr val="1F3B57"/>
+                </a:solidFill>
+              </a:rPr>
+              <a:t>改進版本：std::vector 動態陣列</a:t>
+            </a:r>
+          </a:p>
+        </p:txBody>
+      </p:sp>
+      <p:sp>
+        <p:nvSpPr>
+          <p:cNvPr id="3" name="Rectangle 2"/>
+          <p:cNvSpPr/>
+          <p:nvPr/>
+        </p:nvSpPr>
+        <p:spPr>
+          <a:xfrm>
+            <a:off x="0" y="1143000"/>
+            <a:ext cx="12191695" cy="54864"/>
+          </a:xfrm>
+          <a:prstGeom prst="rect">
+            <a:avLst/>
+          </a:prstGeom>
+          <a:solidFill>
+            <a:srgbClr val="2E86AB"/>
+          </a:solidFill>
+          <a:ln>
+            <a:noFill/>
+          </a:ln>
+          <a:effectLst/>
+        </p:spPr>
+        <p:style>
+          <a:lnRef idx="1">
+            <a:schemeClr val="accent1"/>
+          </a:lnRef>
+          <a:fillRef idx="3">
+            <a:schemeClr val="accent1"/>
+          </a:fillRef>
+          <a:effectRef idx="2">
+            <a:schemeClr val="accent1"/>
+          </a:effectRef>
+          <a:fontRef idx="minor">
+            <a:schemeClr val="lt1"/>
+          </a:fontRef>
+        </p:style>
+        <p:txBody>
+          <a:bodyPr rtlCol="0" anchor="ctr"/>
+          <a:lstStyle/>
+          <a:p>
+            <a:pPr algn="ctr"/>
+          </a:p>
+        </p:txBody>
+      </p:sp>
+      <p:sp>
+        <p:nvSpPr>
+          <p:cNvPr id="4" name="TextBox 3"/>
+          <p:cNvSpPr txBox="1"/>
+          <p:nvPr/>
+        </p:nvSpPr>
+        <p:spPr>
+          <a:xfrm>
+            <a:off x="548640" y="1554480"/>
+            <a:ext cx="6400800" cy="3291840"/>
+          </a:xfrm>
+          <a:prstGeom prst="rect">
+            <a:avLst/>
+          </a:prstGeom>
+          <a:solidFill>
+            <a:srgbClr val="F4F4F4"/>
+          </a:solidFill>
+          <a:ln w="9525">
+            <a:solidFill>
+              <a:srgbClr val="D0D0D0"/>
+            </a:solidFill>
+          </a:ln>
+        </p:spPr>
+        <p:txBody>
+          <a:bodyPr wrap="square" lIns="137160" rIns="137160" tIns="91440" bIns="91440">
+            <a:spAutoFit/>
+          </a:bodyPr>
+          <a:lstStyle/>
+          <a:p>
+            <a:r>
+              <a:rPr sz="1500">
+                <a:solidFill>
+                  <a:srgbClr val="333333"/>
+                </a:solidFill>
+                <a:latin typeface="Consolas"/>
+              </a:rPr>
+              <a:t>vector&lt;int&gt; ans;   // 不用事先宣告大小</a:t>
+            </a:r>
+          </a:p>
+          <a:p>
+            <a:r>
+              <a:rPr sz="1500">
+                <a:solidFill>
+                  <a:srgbClr val="333333"/>
+                </a:solidFill>
+                <a:latin typeface="Consolas"/>
+              </a:rPr>
+              <a:t/>
+            </a:r>
+          </a:p>
+          <a:p>
+            <a:r>
+              <a:rPr sz="1500">
+                <a:solidFill>
+                  <a:srgbClr val="333333"/>
+                </a:solidFill>
+                <a:latin typeface="Consolas"/>
+              </a:rPr>
+              <a:t>for (int i = x; i &lt;= y; i++) {</a:t>
+            </a:r>
+          </a:p>
+          <a:p>
+            <a:r>
+              <a:rPr sz="1500">
+                <a:solidFill>
+                  <a:srgbClr val="333333"/>
+                </a:solidFill>
+                <a:latin typeface="Consolas"/>
+              </a:rPr>
+              <a:t>    if (judge(i)) {</a:t>
+            </a:r>
+          </a:p>
+          <a:p>
+            <a:r>
+              <a:rPr sz="1500">
+                <a:solidFill>
+                  <a:srgbClr val="333333"/>
+                </a:solidFill>
+                <a:latin typeface="Consolas"/>
+              </a:rPr>
+              <a:t>        ans.push_back(i);   // 自動成長，不會越界</a:t>
+            </a:r>
+          </a:p>
+          <a:p>
+            <a:r>
+              <a:rPr sz="1500">
+                <a:solidFill>
+                  <a:srgbClr val="333333"/>
+                </a:solidFill>
+                <a:latin typeface="Consolas"/>
+              </a:rPr>
+              <a:t>    }</a:t>
+            </a:r>
+          </a:p>
+          <a:p>
+            <a:r>
+              <a:rPr sz="1500">
+                <a:solidFill>
+                  <a:srgbClr val="333333"/>
+                </a:solidFill>
+                <a:latin typeface="Consolas"/>
+              </a:rPr>
+              <a:t>}</a:t>
+            </a:r>
+          </a:p>
+          <a:p>
+            <a:r>
+              <a:rPr sz="1500">
+                <a:solidFill>
+                  <a:srgbClr val="333333"/>
+                </a:solidFill>
+                <a:latin typeface="Consolas"/>
+              </a:rPr>
+              <a:t/>
+            </a:r>
+          </a:p>
+          <a:p>
+            <a:r>
+              <a:rPr sz="1500">
+                <a:solidFill>
+                  <a:srgbClr val="333333"/>
+                </a:solidFill>
+                <a:latin typeface="Consolas"/>
+              </a:rPr>
+              <a:t>cout &lt;&lt; ans.size() &lt;&lt; endl;</a:t>
+            </a:r>
+          </a:p>
+          <a:p>
+            <a:r>
+              <a:rPr sz="1500">
+                <a:solidFill>
+                  <a:srgbClr val="333333"/>
+                </a:solidFill>
+                <a:latin typeface="Consolas"/>
+              </a:rPr>
+              <a:t>for (int v : ans) cout &lt;&lt; v &lt;&lt; " ";</a:t>
+            </a:r>
+          </a:p>
+        </p:txBody>
+      </p:sp>
+      <p:sp>
+        <p:nvSpPr>
+          <p:cNvPr id="5" name="TextBox 4"/>
+          <p:cNvSpPr txBox="1"/>
+          <p:nvPr/>
+        </p:nvSpPr>
+        <p:spPr>
+          <a:xfrm>
+            <a:off x="7223760" y="1554480"/>
+            <a:ext cx="4480560" cy="4389120"/>
+          </a:xfrm>
+          <a:prstGeom prst="rect">
+            <a:avLst/>
+          </a:prstGeom>
+          <a:noFill/>
+        </p:spPr>
+        <p:txBody>
+          <a:bodyPr wrap="square">
+            <a:spAutoFit/>
+          </a:bodyPr>
+          <a:lstStyle/>
+          <a:p>
+            <a:pPr>
+              <a:spcAft>
+                <a:spcPts val="1000"/>
+              </a:spcAft>
+            </a:pPr>
+            <a:r>
+              <a:rPr sz="1600">
+                <a:solidFill>
+                  <a:srgbClr val="2B2B2B"/>
+                </a:solidFill>
+              </a:rPr>
+              <a:t>改進效果：</a:t>
+            </a:r>
+          </a:p>
+          <a:p>
+            <a:pPr lvl="1">
+              <a:spcAft>
+                <a:spcPts val="1000"/>
+              </a:spcAft>
+            </a:pPr>
+            <a:r>
+              <a:rPr sz="1400">
+                <a:solidFill>
+                  <a:srgbClr val="2B2B2B"/>
+                </a:solidFill>
+              </a:rPr>
+              <a:t>容量隨資料動態成長，無需事先猜測上限</a:t>
+            </a:r>
+          </a:p>
+          <a:p>
+            <a:pPr lvl="1">
+              <a:spcAft>
+                <a:spcPts val="1000"/>
+              </a:spcAft>
+            </a:pPr>
+            <a:r>
+              <a:rPr sz="1400">
+                <a:solidFill>
+                  <a:srgbClr val="2B2B2B"/>
+                </a:solidFill>
+              </a:rPr>
+              <a:t>消除陣列越界的未定義行為風險</a:t>
+            </a:r>
+          </a:p>
+          <a:p>
+            <a:pPr lvl="1">
+              <a:spcAft>
+                <a:spcPts val="1000"/>
+              </a:spcAft>
+            </a:pPr>
+            <a:r>
+              <a:rPr sz="1400">
+                <a:solidFill>
+                  <a:srgbClr val="2B2B2B"/>
+                </a:solidFill>
+              </a:rPr>
+              <a:t>程式碼更貼近「資料多大就存多大」的直覺</a:t>
+            </a:r>
+          </a:p>
+          <a:p>
+            <a:pPr lvl="1">
+              <a:spcAft>
+                <a:spcPts val="1000"/>
+              </a:spcAft>
+            </a:pPr>
+            <a:r>
+              <a:rPr sz="1400">
+                <a:solidFill>
+                  <a:srgbClr val="2B2B2B"/>
+                </a:solidFill>
+              </a:rPr>
+              <a:t>檔案：演算法之美/練習1-adviced.cpp</a:t>
+            </a:r>
+          </a:p>
+        </p:txBody>
+      </p:sp>
+      <p:sp>
+        <p:nvSpPr>
+          <p:cNvPr id="6" name="TextBox 5"/>
+          <p:cNvSpPr txBox="1"/>
+          <p:nvPr/>
+        </p:nvSpPr>
+        <p:spPr>
+          <a:xfrm>
+            <a:off x="548640" y="6446520"/>
+            <a:ext cx="11064240" cy="320040"/>
+          </a:xfrm>
+          <a:prstGeom prst="rect">
+            <a:avLst/>
+          </a:prstGeom>
+          <a:noFill/>
+        </p:spPr>
+        <p:txBody>
+          <a:bodyPr wrap="none">
+            <a:spAutoFit/>
+          </a:bodyPr>
+          <a:lstStyle/>
+          <a:p>
+            <a:r>
+              <a:rPr sz="1200">
+                <a:solidFill>
+                  <a:srgbClr val="999999"/>
+                </a:solidFill>
+              </a:rPr>
+              <a:t>演算法之美/練習1-adviced.cpp</a:t>
+            </a:r>
+          </a:p>
+        </p:txBody>
+      </p:sp>
+    </p:spTree>
+  </p:cSld>
+  <p:clrMapOvr>
+    <a:masterClrMapping/>
+  </p:clrMapOvr>
+</p:sld>
+</file>
+
+<file path=ppt/slides/slide15.xml><?xml version="1.0" encoding="utf-8"?>
 <p:sld xmlns:a="http://schemas.openxmlformats.org/drawingml/2006/main" xmlns:p="http://schemas.openxmlformats.org/presentationml/2006/main" xmlns:r="http://schemas.openxmlformats.org/officeDocument/2006/relationships">
   <p:cSld>
     <p:spTree>
@@ -4804,7 +5125,7 @@
 </p:sld>
 </file>
 
-<file path=ppt/slides/slide15.xml><?xml version="1.0" encoding="utf-8"?>
+<file path=ppt/slides/slide16.xml><?xml version="1.0" encoding="utf-8"?>
 <p:sld xmlns:a="http://schemas.openxmlformats.org/drawingml/2006/main" xmlns:p="http://schemas.openxmlformats.org/presentationml/2006/main" xmlns:r="http://schemas.openxmlformats.org/officeDocument/2006/relationships">
   <p:cSld>
     <p:spTree>

</xml_diff>